<commit_message>
Verification pass: CI 75 passed on the merged head; deck and model card updated
- final_status.md records the GitHub Actions result on 807f67d (75 passed,
  lint clean) instead of the earlier container count.
- Deck: test-count literal 66 -> 75 (two places); pptx and PDF rebuilt.
- docs/model_card.md: evaluation protocol and limitations now describe the
  three-seed comparison instead of "single seed".
- progress.md Milestone 9: verification bullet, and why the evidence
  registry is not re-exported from the container.

Co-Authored-By: Claude Fable 5.1 <noreply@anthropic.com>
Claude-Session: https://claude.ai/code/session_01TvVDxpKGsTavsxwGgt9Z7v
</commit_message>
<xml_diff>
--- a/presentation/Final_Review_S_K_Sricharan_25MML1010.pptx
+++ b/presentation/Final_Review_S_K_Sricharan_25MML1010.pptx
@@ -7380,7 +7380,7 @@
                 <a:cs typeface="Times New Roman"/>
                 <a:ea typeface="Times New Roman"/>
               </a:rPr>
-              <a:t>66 automated tests: unit, leakage, safety, integration, end-to-end</a:t>
+              <a:t>75 automated tests: unit, leakage, safety, integration, end-to-end (CI, 2026-10-21)</a:t>
             </a:r>
           </a:p>
         </p:txBody>
@@ -21212,7 +21212,7 @@
                 <a:cs typeface="Arial"/>
                 <a:ea typeface="Arial"/>
               </a:rPr>
-              <a:t>66</a:t>
+              <a:t>75</a:t>
             </a:r>
           </a:p>
           <a:p>

</xml_diff>

<commit_message>
Final review deck: test count 82 (CI run 65 on main 354106e)
PR #21 added seven split-calibration tests (75 -> 82). No result,
metric or claim changed; SUMO comparison stays NOT RUN.

Co-Authored-By: Claude Opus 5.5 (1M context) <noreply@anthropic.com>
Claude-Session: https://claude.ai/code/session_0175XpgXXJzxtx2jsZ5HtaSy
</commit_message>
<xml_diff>
--- a/presentation/Final_Review_S_K_Sricharan_25MML1010.pptx
+++ b/presentation/Final_Review_S_K_Sricharan_25MML1010.pptx
@@ -7380,7 +7380,7 @@
                 <a:cs typeface="Times New Roman"/>
                 <a:ea typeface="Times New Roman"/>
               </a:rPr>
-              <a:t>75 automated tests: unit, leakage, safety, integration, end-to-end (CI, 2026-10-21)</a:t>
+              <a:t>82 automated tests: unit, leakage, safety, integration, end-to-end (CI run 65, 2026-10-21)</a:t>
             </a:r>
           </a:p>
         </p:txBody>
@@ -21212,7 +21212,7 @@
                 <a:cs typeface="Arial"/>
                 <a:ea typeface="Arial"/>
               </a:rPr>
-              <a:t>75</a:t>
+              <a:t>82</a:t>
             </a:r>
           </a:p>
           <a:p>

</xml_diff>

<commit_message>
Final review deck: laptop forecast and map screenshots, v5 split-calibration result
- New dashboard slide (1/5) with the Multi-horizon forecast and Traffic map pages
  captured on the workstation (REPLAY), cropped in the builder.
- Slide 21: native chart of simulated speed by corridor green factor from
  simulation_split_calibration_v5_*.csv (5.82 -> 8.10 mph vs 10.95 observed);
  factors 2.0 and 2.5 admissible, none within tolerance, comparison NOT RUN.
- Slides 14, 16, 22, 23 state the calibration outcome and the next step.
- Template asset now has 25 slides (one more dashboard slide).

Co-Authored-By: Claude Opus 5.5 (1M context) <noreply@anthropic.com>
Claude-Session: https://claude.ai/code/session_0175XpgXXJzxtx2jsZ5HtaSy
</commit_message>
<xml_diff>
--- a/presentation/Final_Review_S_K_Sricharan_25MML1010.pptx
+++ b/presentation/Final_Review_S_K_Sricharan_25MML1010.pptx
@@ -28,6 +28,7 @@
     <p:sldId id="340" r:id="rId27"/>
     <p:sldId id="341" r:id="rId28"/>
     <p:sldId id="342" r:id="rId29"/>
+    <p:sldId id="344" r:id="rId31"/>
     <p:sldId id="327" r:id="rId16"/>
     <p:sldId id="343" r:id="rId30"/>
     <p:sldId id="338" r:id="rId25"/>
@@ -713,6 +714,511 @@
       </c:valAx>
     </c:plotArea>
     <c:dispBlanksAs val="gap"/>
+  </c:chart>
+  <c:txPr>
+    <a:bodyPr/>
+    <a:lstStyle/>
+    <a:p>
+      <a:pPr>
+        <a:defRPr sz="1800"/>
+      </a:pPr>
+      <a:endParaRPr lang="en-US"/>
+    </a:p>
+  </c:txPr>
+  <c:externalData r:id="rId1">
+    <c:autoUpdate val="0"/>
+  </c:externalData>
+</c:chartSpace>
+</file>
+
+<file path=ppt/charts/chart3.xml><?xml version="1.0" encoding="utf-8"?>
+<c:chartSpace xmlns:c="http://schemas.openxmlformats.org/drawingml/2006/chart" xmlns:a="http://schemas.openxmlformats.org/drawingml/2006/main" xmlns:r="http://schemas.openxmlformats.org/officeDocument/2006/relationships">
+  <c:date1904 val="0"/>
+  <c:chart>
+    <c:autoTitleDeleted val="0"/>
+    <c:plotArea>
+      <c:lineChart>
+        <c:grouping val="standard"/>
+        <c:varyColors val="0"/>
+        <c:ser>
+          <c:idx val="0"/>
+          <c:order val="0"/>
+          <c:tx>
+            <c:strRef>
+              <c:f>Sheet1!$B$1</c:f>
+              <c:strCache>
+                <c:ptCount val="1"/>
+                <c:pt idx="0">
+                  <c:v>Simulated speed, mean of 3 seeds</c:v>
+                </c:pt>
+              </c:strCache>
+            </c:strRef>
+          </c:tx>
+          <c:spPr>
+            <a:ln w="28575">
+              <a:solidFill>
+                <a:srgbClr val="1F497D"/>
+              </a:solidFill>
+            </a:ln>
+          </c:spPr>
+          <c:marker>
+            <c:spPr>
+              <a:solidFill>
+                <a:srgbClr val="1F497D"/>
+              </a:solidFill>
+              <a:ln>
+                <a:solidFill>
+                  <a:srgbClr val="1F497D"/>
+                </a:solidFill>
+              </a:ln>
+            </c:spPr>
+          </c:marker>
+          <c:dLbls>
+            <c:dLbl>
+              <c:idx val="0"/>
+              <c:spPr/>
+              <c:txPr>
+                <a:bodyPr/>
+                <a:lstStyle/>
+                <a:p>
+                  <a:pPr>
+                    <a:defRPr sz="1000">
+                      <a:solidFill>
+                        <a:srgbClr val="1F497D"/>
+                      </a:solidFill>
+                      <a:latin typeface="Arial"/>
+                    </a:defRPr>
+                  </a:pPr>
+                </a:p>
+              </c:txPr>
+              <c:dLblPos val="t"/>
+              <c:showLegendKey val="0"/>
+              <c:showVal val="1"/>
+              <c:showCatName val="0"/>
+              <c:showSerName val="0"/>
+              <c:showPercent val="0"/>
+              <c:showBubbleSize val="0"/>
+            </c:dLbl>
+            <c:dLbl>
+              <c:idx val="1"/>
+              <c:spPr/>
+              <c:txPr>
+                <a:bodyPr/>
+                <a:lstStyle/>
+                <a:p>
+                  <a:pPr>
+                    <a:defRPr sz="1000">
+                      <a:solidFill>
+                        <a:srgbClr val="1F497D"/>
+                      </a:solidFill>
+                      <a:latin typeface="Arial"/>
+                    </a:defRPr>
+                  </a:pPr>
+                </a:p>
+              </c:txPr>
+              <c:dLblPos val="t"/>
+              <c:showLegendKey val="0"/>
+              <c:showVal val="1"/>
+              <c:showCatName val="0"/>
+              <c:showSerName val="0"/>
+              <c:showPercent val="0"/>
+              <c:showBubbleSize val="0"/>
+            </c:dLbl>
+            <c:dLbl>
+              <c:idx val="2"/>
+              <c:spPr/>
+              <c:txPr>
+                <a:bodyPr/>
+                <a:lstStyle/>
+                <a:p>
+                  <a:pPr>
+                    <a:defRPr sz="1000">
+                      <a:solidFill>
+                        <a:srgbClr val="1F497D"/>
+                      </a:solidFill>
+                      <a:latin typeface="Arial"/>
+                    </a:defRPr>
+                  </a:pPr>
+                </a:p>
+              </c:txPr>
+              <c:dLblPos val="t"/>
+              <c:showLegendKey val="0"/>
+              <c:showVal val="1"/>
+              <c:showCatName val="0"/>
+              <c:showSerName val="0"/>
+              <c:showPercent val="0"/>
+              <c:showBubbleSize val="0"/>
+            </c:dLbl>
+            <c:dLbl>
+              <c:idx val="3"/>
+              <c:spPr/>
+              <c:txPr>
+                <a:bodyPr/>
+                <a:lstStyle/>
+                <a:p>
+                  <a:pPr>
+                    <a:defRPr sz="1000">
+                      <a:solidFill>
+                        <a:srgbClr val="1F497D"/>
+                      </a:solidFill>
+                      <a:latin typeface="Arial"/>
+                    </a:defRPr>
+                  </a:pPr>
+                </a:p>
+              </c:txPr>
+              <c:dLblPos val="t"/>
+              <c:showLegendKey val="0"/>
+              <c:showVal val="1"/>
+              <c:showCatName val="0"/>
+              <c:showSerName val="0"/>
+              <c:showPercent val="0"/>
+              <c:showBubbleSize val="0"/>
+            </c:dLbl>
+            <c:dLbl>
+              <c:idx val="4"/>
+              <c:spPr/>
+              <c:txPr>
+                <a:bodyPr/>
+                <a:lstStyle/>
+                <a:p>
+                  <a:pPr>
+                    <a:defRPr sz="1000">
+                      <a:solidFill>
+                        <a:srgbClr val="1F497D"/>
+                      </a:solidFill>
+                      <a:latin typeface="Arial"/>
+                    </a:defRPr>
+                  </a:pPr>
+                </a:p>
+              </c:txPr>
+              <c:dLblPos val="t"/>
+              <c:showLegendKey val="0"/>
+              <c:showVal val="1"/>
+              <c:showCatName val="0"/>
+              <c:showSerName val="0"/>
+              <c:showPercent val="0"/>
+              <c:showBubbleSize val="0"/>
+            </c:dLbl>
+            <c:dLbl>
+              <c:idx val="5"/>
+              <c:spPr/>
+              <c:txPr>
+                <a:bodyPr/>
+                <a:lstStyle/>
+                <a:p>
+                  <a:pPr>
+                    <a:defRPr sz="1000">
+                      <a:solidFill>
+                        <a:srgbClr val="1F497D"/>
+                      </a:solidFill>
+                      <a:latin typeface="Arial"/>
+                    </a:defRPr>
+                  </a:pPr>
+                </a:p>
+              </c:txPr>
+              <c:dLblPos val="t"/>
+              <c:showLegendKey val="0"/>
+              <c:showVal val="1"/>
+              <c:showCatName val="0"/>
+              <c:showSerName val="0"/>
+              <c:showPercent val="0"/>
+              <c:showBubbleSize val="0"/>
+            </c:dLbl>
+            <c:dLbl>
+              <c:idx val="6"/>
+              <c:spPr/>
+              <c:txPr>
+                <a:bodyPr/>
+                <a:lstStyle/>
+                <a:p>
+                  <a:pPr>
+                    <a:defRPr sz="1000">
+                      <a:solidFill>
+                        <a:srgbClr val="1F497D"/>
+                      </a:solidFill>
+                      <a:latin typeface="Arial"/>
+                    </a:defRPr>
+                  </a:pPr>
+                </a:p>
+              </c:txPr>
+              <c:dLblPos val="t"/>
+              <c:showLegendKey val="0"/>
+              <c:showVal val="1"/>
+              <c:showCatName val="0"/>
+              <c:showSerName val="0"/>
+              <c:showPercent val="0"/>
+              <c:showBubbleSize val="0"/>
+            </c:dLbl>
+            <c:showLegendKey val="0"/>
+            <c:showVal val="0"/>
+            <c:showCatName val="0"/>
+            <c:showSerName val="0"/>
+            <c:showPercent val="0"/>
+            <c:showBubbleSize val="0"/>
+            <c:showLeaderLines val="1"/>
+          </c:dLbls>
+          <c:cat>
+            <c:strRef>
+              <c:f>Sheet1!$A$2:$A$8</c:f>
+              <c:strCache>
+                <c:ptCount val="7"/>
+                <c:pt idx="0">
+                  <c:v>×1.0</c:v>
+                </c:pt>
+                <c:pt idx="1">
+                  <c:v>×1.2</c:v>
+                </c:pt>
+                <c:pt idx="2">
+                  <c:v>×1.4</c:v>
+                </c:pt>
+                <c:pt idx="3">
+                  <c:v>×1.6</c:v>
+                </c:pt>
+                <c:pt idx="4">
+                  <c:v>×1.8</c:v>
+                </c:pt>
+                <c:pt idx="5">
+                  <c:v>×2.0</c:v>
+                </c:pt>
+                <c:pt idx="6">
+                  <c:v>×2.5</c:v>
+                </c:pt>
+              </c:strCache>
+            </c:strRef>
+          </c:cat>
+          <c:val>
+            <c:numRef>
+              <c:f>Sheet1!$B$2:$B$8</c:f>
+              <c:numCache>
+                <c:formatCode>General</c:formatCode>
+                <c:ptCount val="7"/>
+                <c:pt idx="0">
+                  <c:v>5.82</c:v>
+                </c:pt>
+                <c:pt idx="1">
+                  <c:v>6.16</c:v>
+                </c:pt>
+                <c:pt idx="2">
+                  <c:v>6.52</c:v>
+                </c:pt>
+                <c:pt idx="3">
+                  <c:v>6.85</c:v>
+                </c:pt>
+                <c:pt idx="4">
+                  <c:v>7.13</c:v>
+                </c:pt>
+                <c:pt idx="5">
+                  <c:v>7.49</c:v>
+                </c:pt>
+                <c:pt idx="6">
+                  <c:v>8.1</c:v>
+                </c:pt>
+              </c:numCache>
+            </c:numRef>
+          </c:val>
+          <c:smooth val="0"/>
+        </c:ser>
+        <c:ser>
+          <c:idx val="1"/>
+          <c:order val="1"/>
+          <c:tx>
+            <c:strRef>
+              <c:f>Sheet1!$C$1</c:f>
+              <c:strCache>
+                <c:ptCount val="1"/>
+                <c:pt idx="0">
+                  <c:v>Observed PM-peak speed (target)</c:v>
+                </c:pt>
+              </c:strCache>
+            </c:strRef>
+          </c:tx>
+          <c:spPr>
+            <a:ln w="28575">
+              <a:solidFill>
+                <a:srgbClr val="2E7D4F"/>
+              </a:solidFill>
+              <a:prstDash val="dash"/>
+            </a:ln>
+          </c:spPr>
+          <c:marker>
+            <c:symbol val="none"/>
+            <c:spPr>
+              <a:solidFill>
+                <a:srgbClr val="2E7D4F"/>
+              </a:solidFill>
+              <a:ln>
+                <a:solidFill>
+                  <a:srgbClr val="2E7D4F"/>
+                </a:solidFill>
+              </a:ln>
+            </c:spPr>
+          </c:marker>
+          <c:cat>
+            <c:strRef>
+              <c:f>Sheet1!$A$2:$A$8</c:f>
+              <c:strCache>
+                <c:ptCount val="7"/>
+                <c:pt idx="0">
+                  <c:v>×1.0</c:v>
+                </c:pt>
+                <c:pt idx="1">
+                  <c:v>×1.2</c:v>
+                </c:pt>
+                <c:pt idx="2">
+                  <c:v>×1.4</c:v>
+                </c:pt>
+                <c:pt idx="3">
+                  <c:v>×1.6</c:v>
+                </c:pt>
+                <c:pt idx="4">
+                  <c:v>×1.8</c:v>
+                </c:pt>
+                <c:pt idx="5">
+                  <c:v>×2.0</c:v>
+                </c:pt>
+                <c:pt idx="6">
+                  <c:v>×2.5</c:v>
+                </c:pt>
+              </c:strCache>
+            </c:strRef>
+          </c:cat>
+          <c:val>
+            <c:numRef>
+              <c:f>Sheet1!$C$2:$C$8</c:f>
+              <c:numCache>
+                <c:formatCode>General</c:formatCode>
+                <c:ptCount val="7"/>
+                <c:pt idx="0">
+                  <c:v>10.95</c:v>
+                </c:pt>
+                <c:pt idx="1">
+                  <c:v>10.95</c:v>
+                </c:pt>
+                <c:pt idx="2">
+                  <c:v>10.95</c:v>
+                </c:pt>
+                <c:pt idx="3">
+                  <c:v>10.95</c:v>
+                </c:pt>
+                <c:pt idx="4">
+                  <c:v>10.95</c:v>
+                </c:pt>
+                <c:pt idx="5">
+                  <c:v>10.95</c:v>
+                </c:pt>
+                <c:pt idx="6">
+                  <c:v>10.95</c:v>
+                </c:pt>
+              </c:numCache>
+            </c:numRef>
+          </c:val>
+          <c:smooth val="0"/>
+        </c:ser>
+        <c:marker val="1"/>
+        <c:smooth val="0"/>
+        <c:axId val="2118791784"/>
+        <c:axId val="2140495176"/>
+      </c:lineChart>
+      <c:catAx>
+        <c:axId val="2118791784"/>
+        <c:scaling>
+          <c:orientation val="minMax"/>
+        </c:scaling>
+        <c:delete val="0"/>
+        <c:axPos val="b"/>
+        <c:majorTickMark val="out"/>
+        <c:minorTickMark val="none"/>
+        <c:tickLblPos val="nextTo"/>
+        <c:txPr>
+          <a:bodyPr/>
+          <a:lstStyle/>
+          <a:p>
+            <a:pPr>
+              <a:defRPr sz="1000">
+                <a:latin typeface="Arial"/>
+              </a:defRPr>
+            </a:pPr>
+          </a:p>
+        </c:txPr>
+        <c:crossAx val="2140495176"/>
+        <c:crosses val="autoZero"/>
+        <c:auto val="1"/>
+        <c:lblAlgn val="ctr"/>
+        <c:lblOffset val="100"/>
+        <c:noMultiLvlLbl val="0"/>
+      </c:catAx>
+      <c:valAx>
+        <c:axId val="2140495176"/>
+        <c:scaling>
+          <c:max val="12.0"/>
+          <c:min val="4.0"/>
+        </c:scaling>
+        <c:delete val="0"/>
+        <c:axPos val="l"/>
+        <c:majorGridlines>
+          <c:spPr>
+            <a:ln>
+              <a:solidFill>
+                <a:srgbClr val="D9DFE7"/>
+              </a:solidFill>
+            </a:ln>
+          </c:spPr>
+        </c:majorGridlines>
+        <c:title>
+          <c:tx>
+            <c:rich>
+              <a:bodyPr/>
+              <a:lstStyle/>
+              <a:p>
+                <a:r>
+                  <a:rPr sz="1000" b="0">
+                    <a:latin typeface="Arial"/>
+                  </a:rPr>
+                  <a:t>mph on link 4456494</a:t>
+                </a:r>
+              </a:p>
+            </c:rich>
+          </c:tx>
+          <c:layout/>
+          <c:overlay val="0"/>
+        </c:title>
+        <c:majorTickMark val="out"/>
+        <c:minorTickMark val="none"/>
+        <c:tickLblPos val="nextTo"/>
+        <c:txPr>
+          <a:bodyPr/>
+          <a:lstStyle/>
+          <a:p>
+            <a:pPr>
+              <a:defRPr sz="1000">
+                <a:latin typeface="Arial"/>
+              </a:defRPr>
+            </a:pPr>
+          </a:p>
+        </c:txPr>
+        <c:crossAx val="2118791784"/>
+        <c:crosses val="autoZero"/>
+      </c:valAx>
+    </c:plotArea>
+    <c:legend>
+      <c:legendPos val="b"/>
+      <c:layout/>
+      <c:overlay val="0"/>
+      <c:txPr>
+        <a:bodyPr/>
+        <a:lstStyle/>
+        <a:p>
+          <a:pPr>
+            <a:defRPr sz="1100">
+              <a:latin typeface="Arial"/>
+            </a:defRPr>
+          </a:pPr>
+        </a:p>
+      </c:txPr>
+    </c:legend>
+    <c:plotVisOnly val="1"/>
+    <c:dispBlanksAs val="gap"/>
+    <c:showDLblsOverMax val="0"/>
   </c:chart>
   <c:txPr>
     <a:bodyPr/>
@@ -10670,7 +11176,7 @@
                 <a:cs typeface="Times New Roman"/>
                 <a:ea typeface="Times New Roman"/>
               </a:rPr>
-              <a:t>The simulation testbed fails its own baseline test, so the controller comparison is not run.</a:t>
+              <a:t>The simulation testbed still fails its own baseline test after signal-split calibration (8.1 vs 10.95 mph), so the controller comparison is not run.</a:t>
             </a:r>
           </a:p>
         </p:txBody>
@@ -11180,7 +11686,7 @@
         </p:nvGraphicFramePr>
         <p:xfrm>
           <a:off x="6583680" y="2148840"/>
-          <a:ext cx="5760720" cy="2240280"/>
+          <a:ext cx="5760720" cy="2468880"/>
         </p:xfrm>
         <a:graphic>
           <a:graphicData uri="http://schemas.openxmlformats.org/drawingml/2006/table">
@@ -11189,11 +11695,11 @@
                 <a:tableStyleId>{5C22544A-7EE6-4342-B048-85BDC9FD1C3A}</a:tableStyleId>
               </a:tblPr>
               <a:tblGrid>
-                <a:gridCol w="3291840"/>
-                <a:gridCol w="1188720"/>
+                <a:gridCol w="2971800"/>
                 <a:gridCol w="1280160"/>
+                <a:gridCol w="1508760"/>
               </a:tblGrid>
-              <a:tr h="448056">
+              <a:tr h="411480">
                 <a:tc>
                   <a:txBody>
                     <a:bodyPr wrap="square"/>
@@ -11206,7 +11712,7 @@
                         <a:buNone/>
                       </a:pPr>
                       <a:r>
-                        <a:rPr sz="1400" b="1" i="0">
+                        <a:rPr sz="1300" b="1" i="0">
                           <a:solidFill>
                             <a:srgbClr val="FFFFFF"/>
                           </a:solidFill>
@@ -11236,7 +11742,7 @@
                         <a:buNone/>
                       </a:pPr>
                       <a:r>
-                        <a:rPr sz="1400" b="1" i="0">
+                        <a:rPr sz="1300" b="1" i="0">
                           <a:solidFill>
                             <a:srgbClr val="FFFFFF"/>
                           </a:solidFill>
@@ -11266,7 +11772,7 @@
                         <a:buNone/>
                       </a:pPr>
                       <a:r>
-                        <a:rPr sz="1400" b="1" i="0">
+                        <a:rPr sz="1300" b="1" i="0">
                           <a:solidFill>
                             <a:srgbClr val="FFFFFF"/>
                           </a:solidFill>
@@ -11285,7 +11791,7 @@
                   </a:tcPr>
                 </a:tc>
               </a:tr>
-              <a:tr h="448056">
+              <a:tr h="411480">
                 <a:tc>
                   <a:txBody>
                     <a:bodyPr wrap="square"/>
@@ -11298,7 +11804,7 @@
                         <a:buNone/>
                       </a:pPr>
                       <a:r>
-                        <a:rPr sz="1400" b="0" i="0">
+                        <a:rPr sz="1300" b="0" i="0">
                           <a:solidFill>
                             <a:srgbClr val="1A1A1A"/>
                           </a:solidFill>
@@ -11328,7 +11834,7 @@
                         <a:buNone/>
                       </a:pPr>
                       <a:r>
-                        <a:rPr sz="1400" b="0" i="0">
+                        <a:rPr sz="1300" b="0" i="0">
                           <a:solidFill>
                             <a:srgbClr val="1A1A1A"/>
                           </a:solidFill>
@@ -11358,7 +11864,7 @@
                         <a:buNone/>
                       </a:pPr>
                       <a:r>
-                        <a:rPr sz="1400" b="1" i="0">
+                        <a:rPr sz="1300" b="1" i="0">
                           <a:solidFill>
                             <a:srgbClr val="B02A22"/>
                           </a:solidFill>
@@ -11377,7 +11883,7 @@
                   </a:tcPr>
                 </a:tc>
               </a:tr>
-              <a:tr h="448056">
+              <a:tr h="411480">
                 <a:tc>
                   <a:txBody>
                     <a:bodyPr wrap="square"/>
@@ -11390,7 +11896,7 @@
                         <a:buNone/>
                       </a:pPr>
                       <a:r>
-                        <a:rPr sz="1400" b="0" i="0">
+                        <a:rPr sz="1300" b="0" i="0">
                           <a:solidFill>
                             <a:srgbClr val="1A1A1A"/>
                           </a:solidFill>
@@ -11420,7 +11926,7 @@
                         <a:buNone/>
                       </a:pPr>
                       <a:r>
-                        <a:rPr sz="1400" b="0" i="0">
+                        <a:rPr sz="1300" b="0" i="0">
                           <a:solidFill>
                             <a:srgbClr val="1A1A1A"/>
                           </a:solidFill>
@@ -11450,7 +11956,7 @@
                         <a:buNone/>
                       </a:pPr>
                       <a:r>
-                        <a:rPr sz="1400" b="1" i="0">
+                        <a:rPr sz="1300" b="1" i="0">
                           <a:solidFill>
                             <a:srgbClr val="B02A22"/>
                           </a:solidFill>
@@ -11469,7 +11975,7 @@
                   </a:tcPr>
                 </a:tc>
               </a:tr>
-              <a:tr h="448056">
+              <a:tr h="411480">
                 <a:tc>
                   <a:txBody>
                     <a:bodyPr wrap="square"/>
@@ -11482,7 +11988,7 @@
                         <a:buNone/>
                       </a:pPr>
                       <a:r>
-                        <a:rPr sz="1400" b="0" i="0">
+                        <a:rPr sz="1300" b="0" i="0">
                           <a:solidFill>
                             <a:srgbClr val="1A1A1A"/>
                           </a:solidFill>
@@ -11512,7 +12018,7 @@
                         <a:buNone/>
                       </a:pPr>
                       <a:r>
-                        <a:rPr sz="1400" b="0" i="0">
+                        <a:rPr sz="1300" b="0" i="0">
                           <a:solidFill>
                             <a:srgbClr val="1A1A1A"/>
                           </a:solidFill>
@@ -11542,7 +12048,7 @@
                         <a:buNone/>
                       </a:pPr>
                       <a:r>
-                        <a:rPr sz="1400" b="1" i="0">
+                        <a:rPr sz="1300" b="1" i="0">
                           <a:solidFill>
                             <a:srgbClr val="B02A22"/>
                           </a:solidFill>
@@ -11561,7 +12067,7 @@
                   </a:tcPr>
                 </a:tc>
               </a:tr>
-              <a:tr h="448056">
+              <a:tr h="411480">
                 <a:tc>
                   <a:txBody>
                     <a:bodyPr wrap="square"/>
@@ -11574,7 +12080,7 @@
                         <a:buNone/>
                       </a:pPr>
                       <a:r>
-                        <a:rPr sz="1400" b="0" i="0">
+                        <a:rPr sz="1300" b="0" i="0">
                           <a:solidFill>
                             <a:srgbClr val="1A1A1A"/>
                           </a:solidFill>
@@ -11604,7 +12110,7 @@
                         <a:buNone/>
                       </a:pPr>
                       <a:r>
-                        <a:rPr sz="1400" b="0" i="0">
+                        <a:rPr sz="1300" b="0" i="0">
                           <a:solidFill>
                             <a:srgbClr val="1A1A1A"/>
                           </a:solidFill>
@@ -11634,7 +12140,7 @@
                         <a:buNone/>
                       </a:pPr>
                       <a:r>
-                        <a:rPr sz="1400" b="1" i="0">
+                        <a:rPr sz="1300" b="1" i="0">
                           <a:solidFill>
                             <a:srgbClr val="B02A22"/>
                           </a:solidFill>
@@ -11653,6 +12159,98 @@
                   </a:tcPr>
                 </a:tc>
               </a:tr>
+              <a:tr h="411480">
+                <a:tc>
+                  <a:txBody>
+                    <a:bodyPr wrap="square"/>
+                    <a:lstStyle/>
+                    <a:p>
+                      <a:pPr algn="l" marL="0" indent="0">
+                        <a:spcAft>
+                          <a:spcPts val="0"/>
+                        </a:spcAft>
+                        <a:buNone/>
+                      </a:pPr>
+                      <a:r>
+                        <a:rPr sz="1300" b="0" i="0">
+                          <a:solidFill>
+                            <a:srgbClr val="1A1A1A"/>
+                          </a:solidFill>
+                          <a:latin typeface="Times New Roman"/>
+                          <a:cs typeface="Times New Roman"/>
+                          <a:ea typeface="Times New Roman"/>
+                        </a:rPr>
+                        <a:t>v5: 2025 counts, corridor green ×1.0–2.5</a:t>
+                      </a:r>
+                    </a:p>
+                  </a:txBody>
+                  <a:tcPr anchor="ctr">
+                    <a:solidFill>
+                      <a:srgbClr val="E4ECF7"/>
+                    </a:solidFill>
+                  </a:tcPr>
+                </a:tc>
+                <a:tc>
+                  <a:txBody>
+                    <a:bodyPr wrap="square"/>
+                    <a:lstStyle/>
+                    <a:p>
+                      <a:pPr algn="ctr" marL="0" indent="0">
+                        <a:spcAft>
+                          <a:spcPts val="0"/>
+                        </a:spcAft>
+                        <a:buNone/>
+                      </a:pPr>
+                      <a:r>
+                        <a:rPr sz="1300" b="0" i="0">
+                          <a:solidFill>
+                            <a:srgbClr val="1A1A1A"/>
+                          </a:solidFill>
+                          <a:latin typeface="Times New Roman"/>
+                          <a:cs typeface="Times New Roman"/>
+                          <a:ea typeface="Times New Roman"/>
+                        </a:rPr>
+                        <a:t>0–0.5 % at ×2.0+</a:t>
+                      </a:r>
+                    </a:p>
+                  </a:txBody>
+                  <a:tcPr anchor="ctr">
+                    <a:solidFill>
+                      <a:srgbClr val="E4ECF7"/>
+                    </a:solidFill>
+                  </a:tcPr>
+                </a:tc>
+                <a:tc>
+                  <a:txBody>
+                    <a:bodyPr wrap="square"/>
+                    <a:lstStyle/>
+                    <a:p>
+                      <a:pPr algn="ctr" marL="0" indent="0">
+                        <a:spcAft>
+                          <a:spcPts val="0"/>
+                        </a:spcAft>
+                        <a:buNone/>
+                      </a:pPr>
+                      <a:r>
+                        <a:rPr sz="1300" b="1" i="0">
+                          <a:solidFill>
+                            <a:srgbClr val="B02A22"/>
+                          </a:solidFill>
+                          <a:latin typeface="Times New Roman"/>
+                          <a:cs typeface="Times New Roman"/>
+                          <a:ea typeface="Times New Roman"/>
+                        </a:rPr>
+                        <a:t>8.1 of 10.95 mph</a:t>
+                      </a:r>
+                    </a:p>
+                  </a:txBody>
+                  <a:tcPr anchor="ctr">
+                    <a:solidFill>
+                      <a:srgbClr val="E4ECF7"/>
+                    </a:solidFill>
+                  </a:tcPr>
+                </a:tc>
+              </a:tr>
             </a:tbl>
           </a:graphicData>
         </a:graphic>
@@ -11665,8 +12263,8 @@
         </p:nvSpPr>
         <p:spPr>
           <a:xfrm>
-            <a:off x="6583680" y="4480560"/>
-            <a:ext cx="5760720" cy="2240280"/>
+            <a:off x="6583680" y="4681728"/>
+            <a:ext cx="5760720" cy="2057400"/>
           </a:xfrm>
           <a:prstGeom prst="rect">
             <a:avLst/>
@@ -11679,12 +12277,12 @@
           <a:p>
             <a:pPr algn="l" marL="0" indent="0">
               <a:spcAft>
-                <a:spcPts val="500"/>
-              </a:spcAft>
-              <a:buNone/>
-            </a:pPr>
-            <a:r>
-              <a:rPr sz="1200" b="0" i="0">
+                <a:spcPts val="400"/>
+              </a:spcAft>
+              <a:buNone/>
+            </a:pPr>
+            <a:r>
+              <a:rPr sz="1100" b="0" i="0">
                 <a:solidFill>
                   <a:srgbClr val="555F6B"/>
                 </a:solidFill>
@@ -11698,12 +12296,12 @@
           <a:p>
             <a:pPr algn="l" marL="0" indent="0">
               <a:spcAft>
-                <a:spcPts val="500"/>
-              </a:spcAft>
-              <a:buNone/>
-            </a:pPr>
-            <a:r>
-              <a:rPr sz="1300" b="0" i="0">
+                <a:spcPts val="400"/>
+              </a:spcAft>
+              <a:buNone/>
+            </a:pPr>
+            <a:r>
+              <a:rPr sz="1200" b="0" i="0">
                 <a:solidFill>
                   <a:srgbClr val="1A1A1A"/>
                 </a:solidFill>
@@ -11717,12 +12315,12 @@
           <a:p>
             <a:pPr algn="l" marL="0" indent="0">
               <a:spcAft>
-                <a:spcPts val="500"/>
-              </a:spcAft>
-              <a:buNone/>
-            </a:pPr>
-            <a:r>
-              <a:rPr sz="1300" b="0" i="0">
+                <a:spcPts val="400"/>
+              </a:spcAft>
+              <a:buNone/>
+            </a:pPr>
+            <a:r>
+              <a:rPr sz="1200" b="0" i="0">
                 <a:solidFill>
                   <a:srgbClr val="1A1A1A"/>
                 </a:solidFill>
@@ -11736,12 +12334,12 @@
           <a:p>
             <a:pPr algn="l" marL="0" indent="0">
               <a:spcAft>
-                <a:spcPts val="500"/>
-              </a:spcAft>
-              <a:buNone/>
-            </a:pPr>
-            <a:r>
-              <a:rPr sz="1300" b="1" i="0">
+                <a:spcPts val="400"/>
+              </a:spcAft>
+              <a:buNone/>
+            </a:pPr>
+            <a:r>
+              <a:rPr sz="1200" b="1" i="0">
                 <a:solidFill>
                   <a:srgbClr val="1A1A1A"/>
                 </a:solidFill>
@@ -11749,7 +12347,7 @@
                 <a:cs typeface="Times New Roman"/>
                 <a:ea typeface="Times New Roman"/>
               </a:rPr>
-              <a:t>The test was not relaxed: the comparison is reported as not run, and 10.95 mph is now the calibration target.</a:t>
+              <a:t>v5 (23 Oct, 21 runs): more corridor green raises it to 8.1 mph, still 2.85 mph short of the 1.5 mph tolerance. No timing selected; the comparison stays NOT RUN.</a:t>
             </a:r>
           </a:p>
         </p:txBody>
@@ -11829,7 +12427,7 @@
                 <a:latin typeface="Arial" panose="020B0604020202020204" pitchFamily="34" charset="0"/>
                 <a:cs typeface="Arial" panose="020B0604020202020204" pitchFamily="34" charset="0"/>
               </a:rPr>
-              <a:t>8. OUTCOME: WORKING DASHBOARD (1/4)</a:t>
+              <a:t>8. OUTCOME: WORKING DASHBOARD (1/5)</a:t>
             </a:r>
           </a:p>
         </p:txBody>
@@ -11898,7 +12496,7 @@
                 <a:cs typeface="Arial"/>
                 <a:ea typeface="Arial"/>
               </a:rPr>
-              <a:t>Overview &amp; status</a:t>
+              <a:t>Multi-horizon forecast (proposed model)</a:t>
             </a:r>
             <a:r>
               <a:rPr sz="1200" b="0" i="0">
@@ -11909,14 +12507,25 @@
                 <a:cs typeface="Arial"/>
                 <a:ea typeface="Arial"/>
               </a:rPr>
-              <a:t>   (status page, no mode label)</a:t>
+              <a:t>   Mode shown: </a:t>
+            </a:r>
+            <a:r>
+              <a:rPr sz="1200" b="1" i="0">
+                <a:solidFill>
+                  <a:srgbClr val="C25E00"/>
+                </a:solidFill>
+                <a:latin typeface="Arial"/>
+                <a:cs typeface="Arial"/>
+                <a:ea typeface="Arial"/>
+              </a:rPr>
+              <a:t>REPLAY</a:t>
             </a:r>
           </a:p>
         </p:txBody>
       </p:sp>
       <p:pic>
         <p:nvPicPr>
-          <p:cNvPr id="6" name="Dashboard: Overview &amp; status" descr="overview.png"/>
+          <p:cNvPr id="6" name="Dashboard: Multi-horizon forecast (proposed model)" descr="image.png"/>
           <p:cNvPicPr>
             <a:picLocks noChangeAspect="1"/>
           </p:cNvPicPr>
@@ -11931,7 +12540,7 @@
         <p:spPr>
           <a:xfrm>
             <a:off x="502920" y="1984248"/>
-            <a:ext cx="5715000" cy="4366516"/>
+            <a:ext cx="5715000" cy="3981762"/>
           </a:xfrm>
           <a:prstGeom prst="rect">
             <a:avLst/>
@@ -11978,7 +12587,7 @@
                 <a:cs typeface="Arial"/>
                 <a:ea typeface="Arial"/>
               </a:rPr>
-              <a:t>Data audit &amp; provenance</a:t>
+              <a:t>Traffic map: monitored links</a:t>
             </a:r>
             <a:r>
               <a:rPr sz="1200" b="0" i="0">
@@ -12007,7 +12616,7 @@
       </p:sp>
       <p:pic>
         <p:nvPicPr>
-          <p:cNvPr id="8" name="Dashboard: Data audit &amp; provenance" descr="data_audit.png"/>
+          <p:cNvPr id="8" name="Dashboard: Traffic map: monitored links" descr="image.png"/>
           <p:cNvPicPr>
             <a:picLocks noChangeAspect="1"/>
           </p:cNvPicPr>
@@ -12022,7 +12631,7 @@
         <p:spPr>
           <a:xfrm>
             <a:off x="6583680" y="1984248"/>
-            <a:ext cx="5715000" cy="4366516"/>
+            <a:ext cx="5715000" cy="3185409"/>
           </a:xfrm>
           <a:prstGeom prst="rect">
             <a:avLst/>
@@ -12042,7 +12651,7 @@
         </p:nvSpPr>
         <p:spPr>
           <a:xfrm>
-            <a:off x="502920" y="6423916"/>
+            <a:off x="502920" y="6039162"/>
             <a:ext cx="11795760" cy="457200"/>
           </a:xfrm>
           <a:prstGeom prst="rect">
@@ -12069,7 +12678,7 @@
                 <a:cs typeface="Arial"/>
                 <a:ea typeface="Arial"/>
               </a:rPr>
-              <a:t>Screenshots of the project's Streamlit dashboard (src/smartcity/dashboard/app.py) captured on 21 Oct 2026; every number on them is read from committed result files. Live NYC feeds were not reachable from the capture machine, so no LIVE view is shown.</a:t>
+              <a:t>Captured on 23 Oct 2026 on the training laptop, which holds the trained model and the processed NYC DOT data. The forecast is a REPLAY of the held-out test period (origin 20 Oct 2026, 90 % conformal intervals); no LIVE view is shown.</a:t>
             </a:r>
           </a:p>
         </p:txBody>
@@ -12149,7 +12758,7 @@
                 <a:latin typeface="Arial" panose="020B0604020202020204" pitchFamily="34" charset="0"/>
                 <a:cs typeface="Arial" panose="020B0604020202020204" pitchFamily="34" charset="0"/>
               </a:rPr>
-              <a:t>8. OUTCOME: WORKING DASHBOARD (2/4)</a:t>
+              <a:t>8. OUTCOME: WORKING DASHBOARD (2/5)</a:t>
             </a:r>
           </a:p>
         </p:txBody>
@@ -12218,7 +12827,7 @@
                 <a:cs typeface="Arial"/>
                 <a:ea typeface="Arial"/>
               </a:rPr>
-              <a:t>Experiment results</a:t>
+              <a:t>Overview &amp; status</a:t>
             </a:r>
             <a:r>
               <a:rPr sz="1200" b="0" i="0">
@@ -12229,25 +12838,14 @@
                 <a:cs typeface="Arial"/>
                 <a:ea typeface="Arial"/>
               </a:rPr>
-              <a:t>   Mode shown: </a:t>
-            </a:r>
-            <a:r>
-              <a:rPr sz="1200" b="1" i="0">
-                <a:solidFill>
-                  <a:srgbClr val="C25E00"/>
-                </a:solidFill>
-                <a:latin typeface="Arial"/>
-                <a:cs typeface="Arial"/>
-                <a:ea typeface="Arial"/>
-              </a:rPr>
-              <a:t>REPLAY</a:t>
+              <a:t>   (status page, no mode label)</a:t>
             </a:r>
           </a:p>
         </p:txBody>
       </p:sp>
       <p:pic>
         <p:nvPicPr>
-          <p:cNvPr id="6" name="Dashboard: Experiment results" descr="experiments.png"/>
+          <p:cNvPr id="6" name="Dashboard: Overview &amp; status" descr="overview.png"/>
           <p:cNvPicPr>
             <a:picLocks noChangeAspect="1"/>
           </p:cNvPicPr>
@@ -12309,7 +12907,7 @@
                 <a:cs typeface="Arial"/>
                 <a:ea typeface="Arial"/>
               </a:rPr>
-              <a:t>Uncertainty &amp; reliability</a:t>
+              <a:t>Data audit &amp; provenance</a:t>
             </a:r>
             <a:r>
               <a:rPr sz="1200" b="0" i="0">
@@ -12338,7 +12936,7 @@
       </p:sp>
       <p:pic>
         <p:nvPicPr>
-          <p:cNvPr id="8" name="Dashboard: Uncertainty &amp; reliability" descr="uncertainty.png"/>
+          <p:cNvPr id="8" name="Dashboard: Data audit &amp; provenance" descr="data_audit.png"/>
           <p:cNvPicPr>
             <a:picLocks noChangeAspect="1"/>
           </p:cNvPicPr>
@@ -12480,7 +13078,7 @@
                 <a:latin typeface="Arial" panose="020B0604020202020204" pitchFamily="34" charset="0"/>
                 <a:cs typeface="Arial" panose="020B0604020202020204" pitchFamily="34" charset="0"/>
               </a:rPr>
-              <a:t>8. OUTCOME: WORKING DASHBOARD (3/4)</a:t>
+              <a:t>8. OUTCOME: WORKING DASHBOARD (3/5)</a:t>
             </a:r>
           </a:p>
         </p:txBody>
@@ -12549,7 +13147,7 @@
                 <a:cs typeface="Arial"/>
                 <a:ea typeface="Arial"/>
               </a:rPr>
-              <a:t>Explainability (proposed model)</a:t>
+              <a:t>Experiment results</a:t>
             </a:r>
             <a:r>
               <a:rPr sz="1200" b="0" i="0">
@@ -12578,7 +13176,7 @@
       </p:sp>
       <p:pic>
         <p:nvPicPr>
-          <p:cNvPr id="6" name="Dashboard: Explainability (proposed model)" descr="explainability.png"/>
+          <p:cNvPr id="6" name="Dashboard: Experiment results" descr="experiments.png"/>
           <p:cNvPicPr>
             <a:picLocks noChangeAspect="1"/>
           </p:cNvPicPr>
@@ -12640,7 +13238,7 @@
                 <a:cs typeface="Arial"/>
                 <a:ea typeface="Arial"/>
               </a:rPr>
-              <a:t>Agent trace &amp; advisory</a:t>
+              <a:t>Uncertainty &amp; reliability</a:t>
             </a:r>
             <a:r>
               <a:rPr sz="1200" b="0" i="0">
@@ -12669,7 +13267,7 @@
       </p:sp>
       <p:pic>
         <p:nvPicPr>
-          <p:cNvPr id="8" name="Dashboard: Agent trace &amp; advisory" descr="agent.png"/>
+          <p:cNvPr id="8" name="Dashboard: Uncertainty &amp; reliability" descr="uncertainty.png"/>
           <p:cNvPicPr>
             <a:picLocks noChangeAspect="1"/>
           </p:cNvPicPr>
@@ -12731,7 +13329,7 @@
                 <a:cs typeface="Arial"/>
                 <a:ea typeface="Arial"/>
               </a:rPr>
-              <a:t>Screenshots of the project's Streamlit dashboard (src/smartcity/dashboard/app.py) captured on 21 Oct 2026; every number on them is read from committed result files. Live NYC feeds were not reachable from the capture machine, so no LIVE view is shown.</a:t>
+              <a:t>Screenshots of the project's Streamlit dashboard (src/smartcity/dashboard/app.py) captured on 21 Oct 2026; every number on them is read from committed result files. Live NYC feeds were not reachable from the capture machine, so no LIVE view is shown. The Experiment results page shows the seed-42 runs; the three-seed results are on slide 22.</a:t>
             </a:r>
           </a:p>
         </p:txBody>
@@ -13247,7 +13845,7 @@
                 <a:latin typeface="Arial" panose="020B0604020202020204" pitchFamily="34" charset="0"/>
                 <a:cs typeface="Arial" panose="020B0604020202020204" pitchFamily="34" charset="0"/>
               </a:rPr>
-              <a:t>8. OUTCOME: WORKING DASHBOARD (4/4)</a:t>
+              <a:t>8. OUTCOME: WORKING DASHBOARD (4/5)</a:t>
             </a:r>
           </a:p>
         </p:txBody>
@@ -13276,6 +13874,337 @@
             <a:fld id="{C02A2637-A5A3-49FA-B214-6E67543099EF}" type="slidenum">
               <a:rPr lang="en-US" smtClean="0"/>
               <a:t>20</a:t>
+            </a:fld>
+            <a:endParaRPr lang="en-US"/>
+          </a:p>
+        </p:txBody>
+      </p:sp>
+      <p:sp>
+        <p:nvSpPr>
+          <p:cNvPr id="5" name="TextBox 4"/>
+          <p:cNvSpPr txBox="1"/>
+          <p:nvPr/>
+        </p:nvSpPr>
+        <p:spPr>
+          <a:xfrm>
+            <a:off x="502920" y="1600200"/>
+            <a:ext cx="5715000" cy="329184"/>
+          </a:xfrm>
+          <a:prstGeom prst="rect">
+            <a:avLst/>
+          </a:prstGeom>
+          <a:noFill/>
+        </p:spPr>
+        <p:txBody>
+          <a:bodyPr wrap="square" lIns="18288" rIns="18288" tIns="18288" bIns="18288" anchor="b"/>
+          <a:lstStyle/>
+          <a:p>
+            <a:pPr algn="l" marL="0" indent="0">
+              <a:spcAft>
+                <a:spcPts val="0"/>
+              </a:spcAft>
+              <a:buNone/>
+            </a:pPr>
+            <a:r>
+              <a:rPr sz="1400" b="1" i="0">
+                <a:solidFill>
+                  <a:srgbClr val="1F497D"/>
+                </a:solidFill>
+                <a:latin typeface="Arial"/>
+                <a:cs typeface="Arial"/>
+                <a:ea typeface="Arial"/>
+              </a:rPr>
+              <a:t>Explainability (proposed model)</a:t>
+            </a:r>
+            <a:r>
+              <a:rPr sz="1200" b="0" i="0">
+                <a:solidFill>
+                  <a:srgbClr val="555F6B"/>
+                </a:solidFill>
+                <a:latin typeface="Arial"/>
+                <a:cs typeface="Arial"/>
+                <a:ea typeface="Arial"/>
+              </a:rPr>
+              <a:t>   Mode shown: </a:t>
+            </a:r>
+            <a:r>
+              <a:rPr sz="1200" b="1" i="0">
+                <a:solidFill>
+                  <a:srgbClr val="C25E00"/>
+                </a:solidFill>
+                <a:latin typeface="Arial"/>
+                <a:cs typeface="Arial"/>
+                <a:ea typeface="Arial"/>
+              </a:rPr>
+              <a:t>REPLAY</a:t>
+            </a:r>
+          </a:p>
+        </p:txBody>
+      </p:sp>
+      <p:pic>
+        <p:nvPicPr>
+          <p:cNvPr id="6" name="Dashboard: Explainability (proposed model)" descr="explainability.png"/>
+          <p:cNvPicPr>
+            <a:picLocks noChangeAspect="1"/>
+          </p:cNvPicPr>
+          <p:nvPr/>
+        </p:nvPicPr>
+        <p:blipFill>
+          <a:blip r:embed="rId2"/>
+          <a:stretch>
+            <a:fillRect/>
+          </a:stretch>
+        </p:blipFill>
+        <p:spPr>
+          <a:xfrm>
+            <a:off x="502920" y="1984248"/>
+            <a:ext cx="5715000" cy="4366516"/>
+          </a:xfrm>
+          <a:prstGeom prst="rect">
+            <a:avLst/>
+          </a:prstGeom>
+          <a:ln w="12700">
+            <a:solidFill>
+              <a:srgbClr val="C9D3E0"/>
+            </a:solidFill>
+          </a:ln>
+        </p:spPr>
+      </p:pic>
+      <p:sp>
+        <p:nvSpPr>
+          <p:cNvPr id="7" name="TextBox 6"/>
+          <p:cNvSpPr txBox="1"/>
+          <p:nvPr/>
+        </p:nvSpPr>
+        <p:spPr>
+          <a:xfrm>
+            <a:off x="6583680" y="1600200"/>
+            <a:ext cx="5715000" cy="329184"/>
+          </a:xfrm>
+          <a:prstGeom prst="rect">
+            <a:avLst/>
+          </a:prstGeom>
+          <a:noFill/>
+        </p:spPr>
+        <p:txBody>
+          <a:bodyPr wrap="square" lIns="18288" rIns="18288" tIns="18288" bIns="18288" anchor="b"/>
+          <a:lstStyle/>
+          <a:p>
+            <a:pPr algn="l" marL="0" indent="0">
+              <a:spcAft>
+                <a:spcPts val="0"/>
+              </a:spcAft>
+              <a:buNone/>
+            </a:pPr>
+            <a:r>
+              <a:rPr sz="1400" b="1" i="0">
+                <a:solidFill>
+                  <a:srgbClr val="1F497D"/>
+                </a:solidFill>
+                <a:latin typeface="Arial"/>
+                <a:cs typeface="Arial"/>
+                <a:ea typeface="Arial"/>
+              </a:rPr>
+              <a:t>Agent trace &amp; advisory</a:t>
+            </a:r>
+            <a:r>
+              <a:rPr sz="1200" b="0" i="0">
+                <a:solidFill>
+                  <a:srgbClr val="555F6B"/>
+                </a:solidFill>
+                <a:latin typeface="Arial"/>
+                <a:cs typeface="Arial"/>
+                <a:ea typeface="Arial"/>
+              </a:rPr>
+              <a:t>   Mode shown: </a:t>
+            </a:r>
+            <a:r>
+              <a:rPr sz="1200" b="1" i="0">
+                <a:solidFill>
+                  <a:srgbClr val="C25E00"/>
+                </a:solidFill>
+                <a:latin typeface="Arial"/>
+                <a:cs typeface="Arial"/>
+                <a:ea typeface="Arial"/>
+              </a:rPr>
+              <a:t>REPLAY</a:t>
+            </a:r>
+          </a:p>
+        </p:txBody>
+      </p:sp>
+      <p:pic>
+        <p:nvPicPr>
+          <p:cNvPr id="8" name="Dashboard: Agent trace &amp; advisory" descr="agent.png"/>
+          <p:cNvPicPr>
+            <a:picLocks noChangeAspect="1"/>
+          </p:cNvPicPr>
+          <p:nvPr/>
+        </p:nvPicPr>
+        <p:blipFill>
+          <a:blip r:embed="rId3"/>
+          <a:stretch>
+            <a:fillRect/>
+          </a:stretch>
+        </p:blipFill>
+        <p:spPr>
+          <a:xfrm>
+            <a:off x="6583680" y="1984248"/>
+            <a:ext cx="5715000" cy="4366516"/>
+          </a:xfrm>
+          <a:prstGeom prst="rect">
+            <a:avLst/>
+          </a:prstGeom>
+          <a:ln w="12700">
+            <a:solidFill>
+              <a:srgbClr val="C9D3E0"/>
+            </a:solidFill>
+          </a:ln>
+        </p:spPr>
+      </p:pic>
+      <p:sp>
+        <p:nvSpPr>
+          <p:cNvPr id="9" name="TextBox 8"/>
+          <p:cNvSpPr txBox="1"/>
+          <p:nvPr/>
+        </p:nvSpPr>
+        <p:spPr>
+          <a:xfrm>
+            <a:off x="502920" y="6423916"/>
+            <a:ext cx="11795760" cy="457200"/>
+          </a:xfrm>
+          <a:prstGeom prst="rect">
+            <a:avLst/>
+          </a:prstGeom>
+          <a:noFill/>
+        </p:spPr>
+        <p:txBody>
+          <a:bodyPr wrap="square" lIns="18288" rIns="18288" tIns="18288" bIns="18288" anchor="t"/>
+          <a:lstStyle/>
+          <a:p>
+            <a:pPr algn="l" marL="0" indent="0">
+              <a:spcAft>
+                <a:spcPts val="0"/>
+              </a:spcAft>
+              <a:buNone/>
+            </a:pPr>
+            <a:r>
+              <a:rPr sz="1100" b="0" i="0">
+                <a:solidFill>
+                  <a:srgbClr val="555F6B"/>
+                </a:solidFill>
+                <a:latin typeface="Arial"/>
+                <a:cs typeface="Arial"/>
+                <a:ea typeface="Arial"/>
+              </a:rPr>
+              <a:t>Screenshots of the project's Streamlit dashboard (src/smartcity/dashboard/app.py) captured on 21 Oct 2026; every number on them is read from committed result files. Live NYC feeds were not reachable from the capture machine, so no LIVE view is shown. Agent traces end in review, deferral or rejection; nothing is sent to real signals.</a:t>
+            </a:r>
+          </a:p>
+        </p:txBody>
+      </p:sp>
+    </p:spTree>
+    <p:extLst>
+      <p:ext uri="{BB962C8B-B14F-4D97-AF65-F5344CB8AC3E}">
+        <p14:creationId xmlns:p14="http://schemas.microsoft.com/office/powerpoint/2010/main" val="3319743353"/>
+      </p:ext>
+    </p:extLst>
+  </p:cSld>
+  <p:clrMapOvr>
+    <a:masterClrMapping/>
+  </p:clrMapOvr>
+</p:sld>
+</file>
+
+<file path=ppt/slides/slide21.xml><?xml version="1.0" encoding="utf-8"?>
+<p:sld xmlns:a="http://schemas.openxmlformats.org/drawingml/2006/main" xmlns:r="http://schemas.openxmlformats.org/officeDocument/2006/relationships" xmlns:p="http://schemas.openxmlformats.org/presentationml/2006/main">
+  <p:cSld>
+    <p:spTree>
+      <p:nvGrpSpPr>
+        <p:cNvPr id="1" name="">
+          <a:extLst>
+            <a:ext uri="{FF2B5EF4-FFF2-40B4-BE49-F238E27FC236}">
+              <a16:creationId xmlns:a16="http://schemas.microsoft.com/office/drawing/2014/main" id="{D0E88BB3-2A5B-34AC-B39B-BAE5C65E68D6}"/>
+            </a:ext>
+          </a:extLst>
+        </p:cNvPr>
+        <p:cNvGrpSpPr/>
+        <p:nvPr/>
+      </p:nvGrpSpPr>
+      <p:grpSpPr>
+        <a:xfrm>
+          <a:off x="0" y="0"/>
+          <a:ext cx="0" cy="0"/>
+          <a:chOff x="0" y="0"/>
+          <a:chExt cx="0" cy="0"/>
+        </a:xfrm>
+      </p:grpSpPr>
+      <p:sp>
+        <p:nvSpPr>
+          <p:cNvPr id="2" name="Title 1">
+            <a:extLst>
+              <a:ext uri="{FF2B5EF4-FFF2-40B4-BE49-F238E27FC236}">
+                <a16:creationId xmlns:a16="http://schemas.microsoft.com/office/drawing/2014/main" id="{4BD448EB-8A1A-C9A3-3C48-4830472042E6}"/>
+              </a:ext>
+            </a:extLst>
+          </p:cNvPr>
+          <p:cNvSpPr>
+            <a:spLocks noGrp="1"/>
+          </p:cNvSpPr>
+          <p:nvPr>
+            <p:ph type="title"/>
+          </p:nvPr>
+        </p:nvSpPr>
+        <p:spPr>
+          <a:xfrm>
+            <a:off x="0" y="0"/>
+            <a:ext cx="12801600" cy="1512146"/>
+          </a:xfrm>
+          <a:solidFill>
+            <a:srgbClr val="558ED5"/>
+          </a:solidFill>
+        </p:spPr>
+        <p:txBody>
+          <a:bodyPr>
+            <a:normAutofit/>
+          </a:bodyPr>
+          <a:lstStyle/>
+          <a:p>
+            <a:r>
+              <a:rPr lang="en-US" sz="3600" b="1" dirty="0">
+                <a:solidFill>
+                  <a:schemeClr val="bg1"/>
+                </a:solidFill>
+                <a:latin typeface="Arial" panose="020B0604020202020204" pitchFamily="34" charset="0"/>
+                <a:cs typeface="Arial" panose="020B0604020202020204" pitchFamily="34" charset="0"/>
+              </a:rPr>
+              <a:t>8. OUTCOME: WORKING DASHBOARD (5/5)</a:t>
+            </a:r>
+          </a:p>
+        </p:txBody>
+      </p:sp>
+      <p:sp>
+        <p:nvSpPr>
+          <p:cNvPr id="4" name="Slide Number Placeholder 3">
+            <a:extLst>
+              <a:ext uri="{FF2B5EF4-FFF2-40B4-BE49-F238E27FC236}">
+                <a16:creationId xmlns:a16="http://schemas.microsoft.com/office/drawing/2014/main" id="{3C63C818-3FBA-7FB8-3369-BCE4AC4BD8EF}"/>
+              </a:ext>
+            </a:extLst>
+          </p:cNvPr>
+          <p:cNvSpPr>
+            <a:spLocks noGrp="1"/>
+          </p:cNvSpPr>
+          <p:nvPr>
+            <p:ph type="sldNum" sz="quarter" idx="12"/>
+          </p:nvPr>
+        </p:nvSpPr>
+        <p:spPr/>
+        <p:txBody>
+          <a:bodyPr/>
+          <a:lstStyle/>
+          <a:p>
+            <a:fld id="{C02A2637-A5A3-49FA-B214-6E67543099EF}" type="slidenum">
+              <a:rPr lang="en-US" smtClean="0"/>
+              <a:t>21</a:t>
             </a:fld>
             <a:endParaRPr lang="en-US"/>
           </a:p>
@@ -13381,7 +14310,7 @@
         <p:spPr>
           <a:xfrm>
             <a:off x="502920" y="6423916"/>
-            <a:ext cx="11795760" cy="457200"/>
+            <a:ext cx="5715000" cy="274320"/>
           </a:xfrm>
           <a:prstGeom prst="rect">
             <a:avLst/>
@@ -13399,7 +14328,7 @@
               <a:buNone/>
             </a:pPr>
             <a:r>
-              <a:rPr sz="1100" b="0" i="0">
+              <a:rPr sz="1000" b="0" i="0">
                 <a:solidFill>
                   <a:srgbClr val="555F6B"/>
                 </a:solidFill>
@@ -13407,61 +14336,39 @@
                 <a:cs typeface="Arial"/>
                 <a:ea typeface="Arial"/>
               </a:rPr>
-              <a:t>Screenshots of the project's Streamlit dashboard (src/smartcity/dashboard/app.py) captured on 21 Oct 2026; every number on them is read from committed result files. Live NYC feeds were not reachable from the capture machine, so no LIVE view is shown.</a:t>
-            </a:r>
-          </a:p>
-        </p:txBody>
-      </p:sp>
-      <p:sp>
-        <p:nvSpPr>
-          <p:cNvPr id="8" name="Dashboard notes"/>
-          <p:cNvSpPr/>
+              <a:t>Captured 21 Oct 2026 from committed result files; no LIVE view.</a:t>
+            </a:r>
+          </a:p>
+        </p:txBody>
+      </p:sp>
+      <p:sp>
+        <p:nvSpPr>
+          <p:cNvPr id="8" name="TextBox 7"/>
+          <p:cNvSpPr txBox="1"/>
           <p:nvPr/>
         </p:nvSpPr>
         <p:spPr>
           <a:xfrm>
-            <a:off x="6583680" y="1984248"/>
-            <a:ext cx="5715000" cy="4370832"/>
+            <a:off x="6583680" y="1600200"/>
+            <a:ext cx="5715000" cy="329184"/>
           </a:xfrm>
-          <a:prstGeom prst="roundRect">
-            <a:avLst>
-              <a:gd name="adj" fmla="val 8000"/>
-            </a:avLst>
+          <a:prstGeom prst="rect">
+            <a:avLst/>
           </a:prstGeom>
-          <a:solidFill>
-            <a:srgbClr val="E4ECF7"/>
-          </a:solidFill>
-          <a:ln>
-            <a:noFill/>
-          </a:ln>
-          <a:effectLst/>
+          <a:noFill/>
         </p:spPr>
-        <p:style>
-          <a:lnRef idx="1">
-            <a:schemeClr val="accent1"/>
-          </a:lnRef>
-          <a:fillRef idx="3">
-            <a:schemeClr val="accent1"/>
-          </a:fillRef>
-          <a:effectRef idx="2">
-            <a:schemeClr val="accent1"/>
-          </a:effectRef>
-          <a:fontRef idx="minor">
-            <a:schemeClr val="lt1"/>
-          </a:fontRef>
-        </p:style>
-        <p:txBody>
-          <a:bodyPr rtlCol="0" anchor="t" lIns="164592" rIns="164592" tIns="164592" bIns="164592" wrap="square"/>
+        <p:txBody>
+          <a:bodyPr wrap="square" lIns="18288" rIns="18288" tIns="18288" bIns="18288" anchor="b"/>
           <a:lstStyle/>
           <a:p>
             <a:pPr algn="l" marL="0" indent="0">
               <a:spcAft>
-                <a:spcPts val="800"/>
-              </a:spcAft>
-              <a:buNone/>
-            </a:pPr>
-            <a:r>
-              <a:rPr sz="1700" b="1" i="0">
+                <a:spcPts val="0"/>
+              </a:spcAft>
+              <a:buNone/>
+            </a:pPr>
+            <a:r>
+              <a:rPr sz="1400" b="1" i="0">
                 <a:solidFill>
                   <a:srgbClr val="1F497D"/>
                 </a:solidFill>
@@ -13469,59 +14376,80 @@
                 <a:cs typeface="Arial"/>
                 <a:ea typeface="Arial"/>
               </a:rPr>
-              <a:t>What the dashboard shows, and what it does not</a:t>
-            </a:r>
-          </a:p>
-          <a:p>
-            <a:pPr algn="l" marL="274320" indent="-228600">
-              <a:spcAft>
-                <a:spcPts val="800"/>
-              </a:spcAft>
-              <a:buFont typeface="Arial"/>
-              <a:buChar char="•"/>
-            </a:pPr>
-            <a:r>
-              <a:rPr sz="1400" b="0" i="0">
-                <a:solidFill>
-                  <a:srgbClr val="1A1A1A"/>
+              <a:t>Signal-split calibration, protocol v5</a:t>
+            </a:r>
+            <a:r>
+              <a:rPr sz="1200" b="0" i="0">
+                <a:solidFill>
+                  <a:srgbClr val="555F6B"/>
                 </a:solidFill>
                 <a:latin typeface="Arial"/>
                 <a:cs typeface="Arial"/>
                 <a:ea typeface="Arial"/>
               </a:rPr>
-              <a:t>The SUMO page states the first 45-run comparison is SUPERSEDED and the controller comparison NOT RUN, so it shows no simulated gain.</a:t>
-            </a:r>
-          </a:p>
-          <a:p>
-            <a:pPr algn="l" marL="274320" indent="-228600">
-              <a:spcAft>
-                <a:spcPts val="800"/>
-              </a:spcAft>
-              <a:buFont typeface="Arial"/>
-              <a:buChar char="•"/>
-            </a:pPr>
-            <a:r>
-              <a:rPr sz="1400" b="0" i="0">
-                <a:solidFill>
-                  <a:srgbClr val="1A1A1A"/>
+              <a:t>   Mode: </a:t>
+            </a:r>
+            <a:r>
+              <a:rPr sz="1200" b="1" i="0">
+                <a:solidFill>
+                  <a:srgbClr val="6A3FA0"/>
                 </a:solidFill>
                 <a:latin typeface="Arial"/>
                 <a:cs typeface="Arial"/>
                 <a:ea typeface="Arial"/>
               </a:rPr>
-              <a:t>Agent traces end in PENDING_HUMAN_REVIEW, DEFER or REJECT; approval is for simulation only and nothing is sent to real signals.</a:t>
-            </a:r>
-          </a:p>
+              <a:t>SIMULATION</a:t>
+            </a:r>
+          </a:p>
+        </p:txBody>
+      </p:sp>
+      <p:graphicFrame>
+        <p:nvGraphicFramePr>
+          <p:cNvPr id="9" name="Split calibration"/>
+          <p:cNvGraphicFramePr>
+            <a:graphicFrameLocks noGrp="1"/>
+          </p:cNvGraphicFramePr>
+          <p:nvPr/>
+        </p:nvGraphicFramePr>
+        <p:xfrm>
+          <a:off x="6583680" y="1984248"/>
+          <a:ext cx="5715000" cy="2926080"/>
+        </p:xfrm>
+        <a:graphic>
+          <a:graphicData uri="http://schemas.openxmlformats.org/drawingml/2006/chart">
+            <c:chart xmlns:c="http://schemas.openxmlformats.org/drawingml/2006/chart" r:id="rId3"/>
+          </a:graphicData>
+        </a:graphic>
+      </p:graphicFrame>
+      <p:sp>
+        <p:nvSpPr>
+          <p:cNvPr id="10" name="Calibration notes"/>
+          <p:cNvSpPr txBox="1"/>
+          <p:nvPr/>
+        </p:nvSpPr>
+        <p:spPr>
+          <a:xfrm>
+            <a:off x="6583680" y="4983480"/>
+            <a:ext cx="5715000" cy="1417320"/>
+          </a:xfrm>
+          <a:prstGeom prst="rect">
+            <a:avLst/>
+          </a:prstGeom>
+          <a:noFill/>
+        </p:spPr>
+        <p:txBody>
+          <a:bodyPr wrap="square" lIns="36576" rIns="36576" tIns="36576" bIns="36576" anchor="t"/>
+          <a:lstStyle/>
           <a:p>
             <a:pPr algn="l" marL="274320" indent="-228600">
               <a:spcAft>
-                <a:spcPts val="800"/>
+                <a:spcPts val="300"/>
               </a:spcAft>
               <a:buFont typeface="Arial"/>
               <a:buChar char="•"/>
             </a:pPr>
             <a:r>
-              <a:rPr sz="1400" b="0" i="0">
+              <a:rPr sz="1200" b="0" i="0">
                 <a:solidFill>
                   <a:srgbClr val="1A1A1A"/>
                 </a:solidFill>
@@ -13529,19 +14457,19 @@
                 <a:cs typeface="Arial"/>
                 <a:ea typeface="Arial"/>
               </a:rPr>
-              <a:t>Not captured yet: the Multi-horizon forecast and Traffic map pages need the trained model file and processed data held on the training laptop; they will be captured there for the final version.</a:t>
+              <a:t>Corridor green share scaled ×1.0–2.5 (21 fixed-time runs, seeds 101–103, 2025 counts, 23 Oct 2026).</a:t>
             </a:r>
           </a:p>
           <a:p>
             <a:pPr algn="l" marL="274320" indent="-228600">
               <a:spcAft>
-                <a:spcPts val="800"/>
+                <a:spcPts val="300"/>
               </a:spcAft>
               <a:buFont typeface="Arial"/>
               <a:buChar char="•"/>
             </a:pPr>
             <a:r>
-              <a:rPr sz="1400" b="0" i="0">
+              <a:rPr sz="1200" b="0" i="0">
                 <a:solidFill>
                   <a:srgbClr val="1A1A1A"/>
                 </a:solidFill>
@@ -13549,7 +14477,67 @@
                 <a:cs typeface="Arial"/>
                 <a:ea typeface="Arial"/>
               </a:rPr>
-              <a:t>The Experiment results page shows the seed-42 runs; the three-seed results are on slide 21.</a:t>
+              <a:t>Admissible only at ×2.0 and ×2.5 (no teleports, at most 28 of 5,368 trips unfinished); ×1.0–1.8 leave 98–568 unfinished.</a:t>
+            </a:r>
+          </a:p>
+          <a:p>
+            <a:pPr algn="l" marL="274320" indent="-228600">
+              <a:spcAft>
+                <a:spcPts val="300"/>
+              </a:spcAft>
+              <a:buFont typeface="Arial"/>
+              <a:buChar char="•"/>
+            </a:pPr>
+            <a:r>
+              <a:rPr sz="1200" b="1" i="0">
+                <a:solidFill>
+                  <a:srgbClr val="1A1A1A"/>
+                </a:solidFill>
+                <a:latin typeface="Arial"/>
+                <a:cs typeface="Arial"/>
+                <a:ea typeface="Arial"/>
+              </a:rPr>
+              <a:t>Best admissible 8.10 mph is 2.85 mph below 10.95, beyond the 1.5 mph tolerance: no timing selected, controller comparison NOT RUN, rule not relaxed.</a:t>
+            </a:r>
+          </a:p>
+        </p:txBody>
+      </p:sp>
+      <p:sp>
+        <p:nvSpPr>
+          <p:cNvPr id="11" name="TextBox 10"/>
+          <p:cNvSpPr txBox="1"/>
+          <p:nvPr/>
+        </p:nvSpPr>
+        <p:spPr>
+          <a:xfrm>
+            <a:off x="6583680" y="6423916"/>
+            <a:ext cx="5715000" cy="274320"/>
+          </a:xfrm>
+          <a:prstGeom prst="rect">
+            <a:avLst/>
+          </a:prstGeom>
+          <a:noFill/>
+        </p:spPr>
+        <p:txBody>
+          <a:bodyPr wrap="square" lIns="18288" rIns="18288" tIns="18288" bIns="18288" anchor="t"/>
+          <a:lstStyle/>
+          <a:p>
+            <a:pPr algn="l" marL="0" indent="0">
+              <a:spcAft>
+                <a:spcPts val="0"/>
+              </a:spcAft>
+              <a:buNone/>
+            </a:pPr>
+            <a:r>
+              <a:rPr sz="1000" b="0" i="0">
+                <a:solidFill>
+                  <a:srgbClr val="555F6B"/>
+                </a:solidFill>
+                <a:latin typeface="Arial"/>
+                <a:cs typeface="Arial"/>
+                <a:ea typeface="Arial"/>
+              </a:rPr>
+              <a:t>Run 23 Oct, after the capture; from simulation_split_calibration_v5_*.csv</a:t>
             </a:r>
           </a:p>
         </p:txBody>
@@ -13567,7 +14555,7 @@
 </p:sld>
 </file>
 
-<file path=ppt/slides/slide21.xml><?xml version="1.0" encoding="utf-8"?>
+<file path=ppt/slides/slide22.xml><?xml version="1.0" encoding="utf-8"?>
 <p:sld xmlns:a="http://schemas.openxmlformats.org/drawingml/2006/main" xmlns:r="http://schemas.openxmlformats.org/officeDocument/2006/relationships" xmlns:p="http://schemas.openxmlformats.org/presentationml/2006/main">
   <p:cSld>
     <p:spTree>
@@ -13639,7 +14627,7 @@
           <a:p>
             <a:fld id="{C02A2637-A5A3-49FA-B214-6E67543099EF}" type="slidenum">
               <a:rPr lang="en-US" smtClean="0"/>
-              <a:t>21</a:t>
+              <a:t>22</a:t>
             </a:fld>
             <a:endParaRPr lang="en-US"/>
           </a:p>
@@ -15076,7 +16064,7 @@
                 <a:cs typeface="Arial"/>
                 <a:ea typeface="Arial"/>
               </a:rPr>
-              <a:t>removing the availability-aware gate raises MAE by 0.067 mph (95 % CI 0.048–0.086); removing operational weather features lowers it by 0.046 mph (a negative result). No simulated controller gain is claimed: the SUMO testbed fails its own baseline test (5.8 vs 10.95 mph).</a:t>
+              <a:t>removing the availability-aware gate raises MAE by 0.067 mph (95 % CI 0.048–0.086); removing operational weather features lowers it by 0.046 mph (a negative result). No simulated controller gain is claimed: the SUMO testbed fails its own baseline test (8.1 vs 10.95 mph after signal-split calibration).</a:t>
             </a:r>
           </a:p>
         </p:txBody>
@@ -15094,7 +16082,7 @@
 </p:sld>
 </file>
 
-<file path=ppt/slides/slide22.xml><?xml version="1.0" encoding="utf-8"?>
+<file path=ppt/slides/slide23.xml><?xml version="1.0" encoding="utf-8"?>
 <p:sld xmlns:a="http://schemas.openxmlformats.org/drawingml/2006/main" xmlns:r="http://schemas.openxmlformats.org/officeDocument/2006/relationships" xmlns:p="http://schemas.openxmlformats.org/presentationml/2006/main">
   <p:cSld>
     <p:spTree>
@@ -15166,7 +16154,7 @@
           <a:p>
             <a:fld id="{C02A2637-A5A3-49FA-B214-6E67543099EF}" type="slidenum">
               <a:rPr lang="en-US" smtClean="0"/>
-              <a:t>22</a:t>
+              <a:t>23</a:t>
             </a:fld>
             <a:endParaRPr lang="en-US"/>
           </a:p>
@@ -15517,7 +16505,7 @@
                 <a:cs typeface="Arial"/>
                 <a:ea typeface="Arial"/>
               </a:rPr>
-              <a:t>SUMO controller comparison NOT RUN; the first 45-run comparison is superseded</a:t>
+              <a:t>SUMO controller comparison NOT RUN: signal-split calibration (v5, 23 Oct) reaches 8.1 of 10.95 mph; the first 45-run comparison is superseded</a:t>
             </a:r>
           </a:p>
           <a:p>
@@ -15762,7 +16750,7 @@
                 <a:cs typeface="Arial"/>
                 <a:ea typeface="Arial"/>
               </a:rPr>
-              <a:t>Next: calibrate West St signal timing to 10.95 mph or obtain NYC DOT timing plans, then run the comparison</a:t>
+              <a:t>Next: a new preregistered protocol (wider green range) or NYC DOT timing plans, then the comparison</a:t>
             </a:r>
           </a:p>
           <a:p>
@@ -15820,7 +16808,7 @@
 </p:sld>
 </file>
 
-<file path=ppt/slides/slide23.xml><?xml version="1.0" encoding="utf-8"?>
+<file path=ppt/slides/slide24.xml><?xml version="1.0" encoding="utf-8"?>
 <p:sld xmlns:a="http://schemas.openxmlformats.org/drawingml/2006/main" xmlns:r="http://schemas.openxmlformats.org/officeDocument/2006/relationships" xmlns:p="http://schemas.openxmlformats.org/presentationml/2006/main">
   <p:cSld>
     <p:spTree>
@@ -15920,7 +16908,7 @@
           <a:p>
             <a:fld id="{C02A2637-A5A3-49FA-B214-6E67543099EF}" type="slidenum">
               <a:rPr lang="en-US" smtClean="0"/>
-              <a:t>23</a:t>
+              <a:t>24</a:t>
             </a:fld>
             <a:endParaRPr lang="en-US"/>
           </a:p>
@@ -16188,7 +17176,7 @@
 </p:sld>
 </file>
 
-<file path=ppt/slides/slide24.xml><?xml version="1.0" encoding="utf-8"?>
+<file path=ppt/slides/slide25.xml><?xml version="1.0" encoding="utf-8"?>
 <p:sld xmlns:a="http://schemas.openxmlformats.org/drawingml/2006/main" xmlns:r="http://schemas.openxmlformats.org/officeDocument/2006/relationships" xmlns:p="http://schemas.openxmlformats.org/presentationml/2006/main">
   <p:cSld>
     <p:spTree>
@@ -16260,7 +17248,7 @@
           <a:p>
             <a:fld id="{C02A2637-A5A3-49FA-B214-6E67543099EF}" type="slidenum">
               <a:rPr lang="en-US" smtClean="0"/>
-              <a:t>24</a:t>
+              <a:t>25</a:t>
             </a:fld>
             <a:endParaRPr lang="en-US"/>
           </a:p>

</xml_diff>

<commit_message>
Final review deck: 95 tests, next step is preregistered protocol v6 (not run)
Main 39e44a5 (PR #25) collects 95 tests and holds the v6 split-calibration
protocol, prepared and NOT RUN. No result or figure changed.

Co-Authored-By: Claude Opus 5.5 (1M context) <noreply@anthropic.com>
Claude-Session: https://claude.ai/code/session_0175XpgXXJzxtx2jsZ5HtaSy
</commit_message>
<xml_diff>
--- a/presentation/Final_Review_S_K_Sricharan_25MML1010.pptx
+++ b/presentation/Final_Review_S_K_Sricharan_25MML1010.pptx
@@ -7886,7 +7886,7 @@
                 <a:cs typeface="Times New Roman"/>
                 <a:ea typeface="Times New Roman"/>
               </a:rPr>
-              <a:t>82 automated tests: unit, leakage, safety, integration, end-to-end (CI run 65, 2026-10-21)</a:t>
+              <a:t>95 automated tests: unit, leakage, safety, integration, end-to-end (CI, 2026-10-25)</a:t>
             </a:r>
           </a:p>
         </p:txBody>
@@ -16750,7 +16750,7 @@
                 <a:cs typeface="Arial"/>
                 <a:ea typeface="Arial"/>
               </a:rPr>
-              <a:t>Next: a new preregistered protocol (wider green range) or NYC DOT timing plans, then the comparison</a:t>
+              <a:t>Next: run preregistered protocol v6 (cycle × green × offsets, 75 runs; prepared, not run), then the comparison</a:t>
             </a:r>
           </a:p>
           <a:p>
@@ -22200,7 +22200,7 @@
                 <a:cs typeface="Arial"/>
                 <a:ea typeface="Arial"/>
               </a:rPr>
-              <a:t>82</a:t>
+              <a:t>95</a:t>
             </a:r>
           </a:p>
           <a:p>

</xml_diff>

<commit_message>
Deck: LIVE check slide with the 30 October latest-available run
Adds slide 23 (results and outcomes: LIVE check) with the dashboard's Live
monitoring page (LIVE label), the scored MAE / persistence / coverage / width
per horizon (n = 39) and the eligible-links MAE (n = 30), the three origins
and their data age, and the required caveats: a forecast at the feed's own
latency of bins it had not yet published, with its data age, not real-time;
one afternoon, three origins, not a second test set; the wall-clock protocol
of 28 and 29 October stays NOT RUN. The status slide and dashboard notes no
longer say LIVE was not run. Template now has 26 slides.

Co-Authored-By: Claude Opus 5.5 <noreply@anthropic.com>
Claude-Session: https://claude.ai/code/session_0175XpgXXJzxtx2jsZ5HtaSy
</commit_message>
<xml_diff>
--- a/presentation/Final_Review_S_K_Sricharan_25MML1010.pptx
+++ b/presentation/Final_Review_S_K_Sricharan_25MML1010.pptx
@@ -30,6 +30,7 @@
     <p:sldId id="342" r:id="rId29"/>
     <p:sldId id="344" r:id="rId31"/>
     <p:sldId id="327" r:id="rId16"/>
+    <p:sldId id="345" r:id="rId32"/>
     <p:sldId id="343" r:id="rId30"/>
     <p:sldId id="338" r:id="rId25"/>
     <p:sldId id="321" r:id="rId17"/>
@@ -12341,7 +12342,7 @@
                 <a:cs typeface="Arial"/>
                 <a:ea typeface="Arial"/>
               </a:rPr>
-              <a:t>Captured on 23 Oct 2026 on the training laptop, which holds the trained model and the processed NYC DOT data. The forecast is a REPLAY of the held-out test period (origin 20 Oct 2026, 90 % conformal intervals); no LIVE view is shown.</a:t>
+              <a:t>Captured on 23 Oct 2026 on the training laptop, which holds the trained model and the processed NYC DOT data. The forecast is a REPLAY of the held-out test period (origin 20 Oct 2026, 90 % conformal intervals); the LIVE page is on slide 23.</a:t>
             </a:r>
           </a:p>
         </p:txBody>
@@ -12661,7 +12662,7 @@
                 <a:cs typeface="Arial"/>
                 <a:ea typeface="Arial"/>
               </a:rPr>
-              <a:t>Screenshots of the project's Streamlit dashboard (src/smartcity/dashboard/app.py) captured on 28 Oct 2026; every number on them is read from committed result files. LIVE mode is built but not yet run, so no LIVE view is shown.</a:t>
+              <a:t>Screenshots of the project's Streamlit dashboard (src/smartcity/dashboard/app.py) captured on 28 Oct 2026; every number on them is read from committed result files. The LIVE page, run on 30 Oct 2026, is on slide 23.</a:t>
             </a:r>
           </a:p>
         </p:txBody>
@@ -12992,7 +12993,7 @@
                 <a:cs typeface="Arial"/>
                 <a:ea typeface="Arial"/>
               </a:rPr>
-              <a:t>Screenshots of the project's Streamlit dashboard (src/smartcity/dashboard/app.py) captured on 28 Oct 2026; every number on them is read from committed result files. LIVE mode is built but not yet run, so no LIVE view is shown. The Experiment results page shows the seed-42 runs; the three-seed results are on slide 22.</a:t>
+              <a:t>Screenshots of the project's Streamlit dashboard (src/smartcity/dashboard/app.py) captured on 28 Oct 2026; every number on them is read from committed result files. The LIVE page, run on 30 Oct 2026, is on slide 23. The Experiment results page shows the seed-42 runs; the three-seed results are on slide 22.</a:t>
             </a:r>
           </a:p>
         </p:txBody>
@@ -13759,7 +13760,7 @@
                 <a:cs typeface="Arial"/>
                 <a:ea typeface="Arial"/>
               </a:rPr>
-              <a:t>Screenshots of the project's Streamlit dashboard (src/smartcity/dashboard/app.py) captured on 28 Oct 2026; every number on them is read from committed result files. LIVE mode is built but not yet run, so no LIVE view is shown. Agent traces end in review, deferral or rejection; nothing is sent to real signals.</a:t>
+              <a:t>Screenshots of the project's Streamlit dashboard (src/smartcity/dashboard/app.py) captured on 28 Oct 2026; every number on them is read from committed result files. The LIVE page, run on 30 Oct 2026, is on slide 23. Agent traces end in review, deferral or rejection; nothing is sent to real signals.</a:t>
             </a:r>
           </a:p>
         </p:txBody>
@@ -15795,7 +15796,7 @@
                 <a:latin typeface="Arial" panose="020B0604020202020204" pitchFamily="34" charset="0"/>
                 <a:cs typeface="Arial" panose="020B0604020202020204" pitchFamily="34" charset="0"/>
               </a:rPr>
-              <a:t>9. RESULTS &amp; OUTCOMES (CONTD.)</a:t>
+              <a:t>9. RESULTS &amp; OUTCOMES: LIVE CHECK</a:t>
             </a:r>
           </a:p>
         </p:txBody>
@@ -15818,6 +15819,1246 @@
             <a:fld id="{C02A2637-A5A3-49FA-B214-6E67543099EF}" type="slidenum">
               <a:rPr lang="en-US" smtClean="0"/>
               <a:t>23</a:t>
+            </a:fld>
+            <a:endParaRPr lang="en-US"/>
+          </a:p>
+        </p:txBody>
+      </p:sp>
+      <p:sp>
+        <p:nvSpPr>
+          <p:cNvPr id="5" name="TextBox 4"/>
+          <p:cNvSpPr txBox="1"/>
+          <p:nvPr/>
+        </p:nvSpPr>
+        <p:spPr>
+          <a:xfrm>
+            <a:off x="502920" y="1554480"/>
+            <a:ext cx="5715000" cy="329184"/>
+          </a:xfrm>
+          <a:prstGeom prst="rect">
+            <a:avLst/>
+          </a:prstGeom>
+          <a:noFill/>
+        </p:spPr>
+        <p:txBody>
+          <a:bodyPr wrap="square" lIns="18288" rIns="18288" tIns="18288" bIns="18288" anchor="b"/>
+          <a:lstStyle/>
+          <a:p>
+            <a:pPr algn="l" marL="0" indent="0">
+              <a:spcAft>
+                <a:spcPts val="0"/>
+              </a:spcAft>
+              <a:buNone/>
+            </a:pPr>
+            <a:r>
+              <a:rPr sz="1400" b="1" i="0">
+                <a:solidFill>
+                  <a:srgbClr val="1F497D"/>
+                </a:solidFill>
+                <a:latin typeface="Arial"/>
+                <a:cs typeface="Arial"/>
+                <a:ea typeface="Arial"/>
+              </a:rPr>
+              <a:t>Live monitoring</a:t>
+            </a:r>
+            <a:r>
+              <a:rPr sz="1200" b="0" i="0">
+                <a:solidFill>
+                  <a:srgbClr val="555F6B"/>
+                </a:solidFill>
+                <a:latin typeface="Arial"/>
+                <a:cs typeface="Arial"/>
+                <a:ea typeface="Arial"/>
+              </a:rPr>
+              <a:t>   Mode shown: </a:t>
+            </a:r>
+            <a:r>
+              <a:rPr sz="1200" b="1" i="0">
+                <a:solidFill>
+                  <a:srgbClr val="2E7D4F"/>
+                </a:solidFill>
+                <a:latin typeface="Arial"/>
+                <a:cs typeface="Arial"/>
+                <a:ea typeface="Arial"/>
+              </a:rPr>
+              <a:t>LIVE</a:t>
+            </a:r>
+          </a:p>
+        </p:txBody>
+      </p:sp>
+      <p:pic>
+        <p:nvPicPr>
+          <p:cNvPr id="6" name="Dashboard: Live monitoring" descr="image.png"/>
+          <p:cNvPicPr>
+            <a:picLocks noChangeAspect="1"/>
+          </p:cNvPicPr>
+          <p:nvPr/>
+        </p:nvPicPr>
+        <p:blipFill>
+          <a:blip r:embed="rId2"/>
+          <a:stretch>
+            <a:fillRect/>
+          </a:stretch>
+        </p:blipFill>
+        <p:spPr>
+          <a:xfrm>
+            <a:off x="502920" y="1938528"/>
+            <a:ext cx="5715000" cy="2227881"/>
+          </a:xfrm>
+          <a:prstGeom prst="rect">
+            <a:avLst/>
+          </a:prstGeom>
+          <a:ln w="12700">
+            <a:solidFill>
+              <a:srgbClr val="C9D3E0"/>
+            </a:solidFill>
+          </a:ln>
+        </p:spPr>
+      </p:pic>
+      <p:sp>
+        <p:nvSpPr>
+          <p:cNvPr id="7" name="TextBox 6"/>
+          <p:cNvSpPr txBox="1"/>
+          <p:nvPr/>
+        </p:nvSpPr>
+        <p:spPr>
+          <a:xfrm>
+            <a:off x="502920" y="4212129"/>
+            <a:ext cx="5715000" cy="329184"/>
+          </a:xfrm>
+          <a:prstGeom prst="rect">
+            <a:avLst/>
+          </a:prstGeom>
+          <a:noFill/>
+        </p:spPr>
+        <p:txBody>
+          <a:bodyPr wrap="square" lIns="18288" rIns="18288" tIns="18288" bIns="18288" anchor="b"/>
+          <a:lstStyle/>
+          <a:p>
+            <a:pPr algn="l" marL="0" indent="0">
+              <a:spcAft>
+                <a:spcPts val="0"/>
+              </a:spcAft>
+              <a:buNone/>
+            </a:pPr>
+            <a:r>
+              <a:rPr sz="1400" b="1" i="0">
+                <a:solidFill>
+                  <a:srgbClr val="1F497D"/>
+                </a:solidFill>
+                <a:latin typeface="Arial"/>
+                <a:cs typeface="Arial"/>
+                <a:ea typeface="Arial"/>
+              </a:rPr>
+              <a:t>Forecasts vs later observations</a:t>
+            </a:r>
+            <a:r>
+              <a:rPr sz="1200" b="0" i="0">
+                <a:solidFill>
+                  <a:srgbClr val="555F6B"/>
+                </a:solidFill>
+                <a:latin typeface="Arial"/>
+                <a:cs typeface="Arial"/>
+                <a:ea typeface="Arial"/>
+              </a:rPr>
+              <a:t>   Mode shown: </a:t>
+            </a:r>
+            <a:r>
+              <a:rPr sz="1200" b="1" i="0">
+                <a:solidFill>
+                  <a:srgbClr val="2E7D4F"/>
+                </a:solidFill>
+                <a:latin typeface="Arial"/>
+                <a:cs typeface="Arial"/>
+                <a:ea typeface="Arial"/>
+              </a:rPr>
+              <a:t>LIVE</a:t>
+            </a:r>
+          </a:p>
+        </p:txBody>
+      </p:sp>
+      <p:pic>
+        <p:nvPicPr>
+          <p:cNvPr id="8" name="Dashboard: Forecasts vs later observations" descr="image.png"/>
+          <p:cNvPicPr>
+            <a:picLocks noChangeAspect="1"/>
+          </p:cNvPicPr>
+          <p:nvPr/>
+        </p:nvPicPr>
+        <p:blipFill>
+          <a:blip r:embed="rId3"/>
+          <a:stretch>
+            <a:fillRect/>
+          </a:stretch>
+        </p:blipFill>
+        <p:spPr>
+          <a:xfrm>
+            <a:off x="502920" y="4596177"/>
+            <a:ext cx="5715000" cy="1775847"/>
+          </a:xfrm>
+          <a:prstGeom prst="rect">
+            <a:avLst/>
+          </a:prstGeom>
+          <a:ln w="12700">
+            <a:solidFill>
+              <a:srgbClr val="C9D3E0"/>
+            </a:solidFill>
+          </a:ln>
+        </p:spPr>
+      </p:pic>
+      <p:sp>
+        <p:nvSpPr>
+          <p:cNvPr id="9" name="TextBox 8"/>
+          <p:cNvSpPr txBox="1"/>
+          <p:nvPr/>
+        </p:nvSpPr>
+        <p:spPr>
+          <a:xfrm>
+            <a:off x="6583680" y="1554480"/>
+            <a:ext cx="5715000" cy="329184"/>
+          </a:xfrm>
+          <a:prstGeom prst="rect">
+            <a:avLst/>
+          </a:prstGeom>
+          <a:noFill/>
+        </p:spPr>
+        <p:txBody>
+          <a:bodyPr wrap="square" lIns="18288" rIns="18288" tIns="18288" bIns="18288" anchor="b"/>
+          <a:lstStyle/>
+          <a:p>
+            <a:pPr algn="l" marL="0" indent="0">
+              <a:spcAft>
+                <a:spcPts val="0"/>
+              </a:spcAft>
+              <a:buNone/>
+            </a:pPr>
+            <a:r>
+              <a:rPr sz="1400" b="1" i="0">
+                <a:solidFill>
+                  <a:srgbClr val="1F497D"/>
+                </a:solidFill>
+                <a:latin typeface="Arial"/>
+                <a:cs typeface="Arial"/>
+                <a:ea typeface="Arial"/>
+              </a:rPr>
+              <a:t>Scored LIVE forecasts, 30 Oct 2026</a:t>
+            </a:r>
+            <a:r>
+              <a:rPr sz="1200" b="0" i="0">
+                <a:solidFill>
+                  <a:srgbClr val="555F6B"/>
+                </a:solidFill>
+                <a:latin typeface="Arial"/>
+                <a:cs typeface="Arial"/>
+                <a:ea typeface="Arial"/>
+              </a:rPr>
+              <a:t>   Mode: </a:t>
+            </a:r>
+            <a:r>
+              <a:rPr sz="1200" b="1" i="0">
+                <a:solidFill>
+                  <a:srgbClr val="2E7D4F"/>
+                </a:solidFill>
+                <a:latin typeface="Arial"/>
+                <a:cs typeface="Arial"/>
+                <a:ea typeface="Arial"/>
+              </a:rPr>
+              <a:t>LIVE</a:t>
+            </a:r>
+          </a:p>
+        </p:txBody>
+      </p:sp>
+      <p:graphicFrame>
+        <p:nvGraphicFramePr>
+          <p:cNvPr id="10" name="LIVE scores"/>
+          <p:cNvGraphicFramePr>
+            <a:graphicFrameLocks noGrp="1"/>
+          </p:cNvGraphicFramePr>
+          <p:nvPr/>
+        </p:nvGraphicFramePr>
+        <p:xfrm>
+          <a:off x="6583680" y="1938528"/>
+          <a:ext cx="5715000" cy="1737360"/>
+        </p:xfrm>
+        <a:graphic>
+          <a:graphicData uri="http://schemas.openxmlformats.org/drawingml/2006/table">
+            <a:tbl>
+              <a:tblPr firstRow="1" bandRow="1">
+                <a:tableStyleId>{5C22544A-7EE6-4342-B048-85BDC9FD1C3A}</a:tableStyleId>
+              </a:tblPr>
+              <a:tblGrid>
+                <a:gridCol w="1463040"/>
+                <a:gridCol w="1097280"/>
+                <a:gridCol w="1097280"/>
+                <a:gridCol w="1097280"/>
+                <a:gridCol w="960120"/>
+              </a:tblGrid>
+              <a:tr h="347472">
+                <a:tc>
+                  <a:txBody>
+                    <a:bodyPr wrap="square"/>
+                    <a:lstStyle/>
+                    <a:p>
+                      <a:pPr algn="l" marL="0" indent="0">
+                        <a:spcAft>
+                          <a:spcPts val="0"/>
+                        </a:spcAft>
+                        <a:buNone/>
+                      </a:pPr>
+                      <a:r>
+                        <a:rPr sz="1200" b="1" i="0">
+                          <a:solidFill>
+                            <a:srgbClr val="FFFFFF"/>
+                          </a:solidFill>
+                          <a:latin typeface="Arial"/>
+                          <a:cs typeface="Arial"/>
+                          <a:ea typeface="Arial"/>
+                        </a:rPr>
+                        <a:t>Horizon</a:t>
+                      </a:r>
+                    </a:p>
+                  </a:txBody>
+                  <a:tcPr anchor="ctr">
+                    <a:solidFill>
+                      <a:srgbClr val="1F497D"/>
+                    </a:solidFill>
+                  </a:tcPr>
+                </a:tc>
+                <a:tc>
+                  <a:txBody>
+                    <a:bodyPr wrap="square"/>
+                    <a:lstStyle/>
+                    <a:p>
+                      <a:pPr algn="ctr" marL="0" indent="0">
+                        <a:spcAft>
+                          <a:spcPts val="0"/>
+                        </a:spcAft>
+                        <a:buNone/>
+                      </a:pPr>
+                      <a:r>
+                        <a:rPr sz="1200" b="1" i="0">
+                          <a:solidFill>
+                            <a:srgbClr val="FFFFFF"/>
+                          </a:solidFill>
+                          <a:latin typeface="Arial"/>
+                          <a:cs typeface="Arial"/>
+                          <a:ea typeface="Arial"/>
+                        </a:rPr>
+                        <a:t>MAE (mph)</a:t>
+                      </a:r>
+                    </a:p>
+                  </a:txBody>
+                  <a:tcPr anchor="ctr">
+                    <a:solidFill>
+                      <a:srgbClr val="1F497D"/>
+                    </a:solidFill>
+                  </a:tcPr>
+                </a:tc>
+                <a:tc>
+                  <a:txBody>
+                    <a:bodyPr wrap="square"/>
+                    <a:lstStyle/>
+                    <a:p>
+                      <a:pPr algn="ctr" marL="0" indent="0">
+                        <a:spcAft>
+                          <a:spcPts val="0"/>
+                        </a:spcAft>
+                        <a:buNone/>
+                      </a:pPr>
+                      <a:r>
+                        <a:rPr sz="1200" b="1" i="0">
+                          <a:solidFill>
+                            <a:srgbClr val="FFFFFF"/>
+                          </a:solidFill>
+                          <a:latin typeface="Arial"/>
+                          <a:cs typeface="Arial"/>
+                          <a:ea typeface="Arial"/>
+                        </a:rPr>
+                        <a:t>Persistence</a:t>
+                      </a:r>
+                    </a:p>
+                  </a:txBody>
+                  <a:tcPr anchor="ctr">
+                    <a:solidFill>
+                      <a:srgbClr val="1F497D"/>
+                    </a:solidFill>
+                  </a:tcPr>
+                </a:tc>
+                <a:tc>
+                  <a:txBody>
+                    <a:bodyPr wrap="square"/>
+                    <a:lstStyle/>
+                    <a:p>
+                      <a:pPr algn="ctr" marL="0" indent="0">
+                        <a:spcAft>
+                          <a:spcPts val="0"/>
+                        </a:spcAft>
+                        <a:buNone/>
+                      </a:pPr>
+                      <a:r>
+                        <a:rPr sz="1200" b="1" i="0">
+                          <a:solidFill>
+                            <a:srgbClr val="FFFFFF"/>
+                          </a:solidFill>
+                          <a:latin typeface="Arial"/>
+                          <a:cs typeface="Arial"/>
+                          <a:ea typeface="Arial"/>
+                        </a:rPr>
+                        <a:t>90 % coverage</a:t>
+                      </a:r>
+                    </a:p>
+                  </a:txBody>
+                  <a:tcPr anchor="ctr">
+                    <a:solidFill>
+                      <a:srgbClr val="1F497D"/>
+                    </a:solidFill>
+                  </a:tcPr>
+                </a:tc>
+                <a:tc>
+                  <a:txBody>
+                    <a:bodyPr wrap="square"/>
+                    <a:lstStyle/>
+                    <a:p>
+                      <a:pPr algn="ctr" marL="0" indent="0">
+                        <a:spcAft>
+                          <a:spcPts val="0"/>
+                        </a:spcAft>
+                        <a:buNone/>
+                      </a:pPr>
+                      <a:r>
+                        <a:rPr sz="1200" b="1" i="0">
+                          <a:solidFill>
+                            <a:srgbClr val="FFFFFF"/>
+                          </a:solidFill>
+                          <a:latin typeface="Arial"/>
+                          <a:cs typeface="Arial"/>
+                          <a:ea typeface="Arial"/>
+                        </a:rPr>
+                        <a:t>Width (mph)</a:t>
+                      </a:r>
+                    </a:p>
+                  </a:txBody>
+                  <a:tcPr anchor="ctr">
+                    <a:solidFill>
+                      <a:srgbClr val="1F497D"/>
+                    </a:solidFill>
+                  </a:tcPr>
+                </a:tc>
+              </a:tr>
+              <a:tr h="347472">
+                <a:tc>
+                  <a:txBody>
+                    <a:bodyPr wrap="square"/>
+                    <a:lstStyle/>
+                    <a:p>
+                      <a:pPr algn="l" marL="0" indent="0">
+                        <a:spcAft>
+                          <a:spcPts val="0"/>
+                        </a:spcAft>
+                        <a:buNone/>
+                      </a:pPr>
+                      <a:r>
+                        <a:rPr sz="1200" b="0" i="0">
+                          <a:solidFill>
+                            <a:srgbClr val="1A1A1A"/>
+                          </a:solidFill>
+                          <a:latin typeface="Arial"/>
+                          <a:cs typeface="Arial"/>
+                          <a:ea typeface="Arial"/>
+                        </a:rPr>
+                        <a:t>15 min</a:t>
+                      </a:r>
+                    </a:p>
+                  </a:txBody>
+                  <a:tcPr anchor="ctr">
+                    <a:solidFill>
+                      <a:srgbClr val="E4ECF7"/>
+                    </a:solidFill>
+                  </a:tcPr>
+                </a:tc>
+                <a:tc>
+                  <a:txBody>
+                    <a:bodyPr wrap="square"/>
+                    <a:lstStyle/>
+                    <a:p>
+                      <a:pPr algn="ctr" marL="0" indent="0">
+                        <a:spcAft>
+                          <a:spcPts val="0"/>
+                        </a:spcAft>
+                        <a:buNone/>
+                      </a:pPr>
+                      <a:r>
+                        <a:rPr sz="1200" b="0" i="0">
+                          <a:solidFill>
+                            <a:srgbClr val="1A1A1A"/>
+                          </a:solidFill>
+                          <a:latin typeface="Arial"/>
+                          <a:cs typeface="Arial"/>
+                          <a:ea typeface="Arial"/>
+                        </a:rPr>
+                        <a:t>3.62</a:t>
+                      </a:r>
+                    </a:p>
+                  </a:txBody>
+                  <a:tcPr anchor="ctr">
+                    <a:solidFill>
+                      <a:srgbClr val="E4ECF7"/>
+                    </a:solidFill>
+                  </a:tcPr>
+                </a:tc>
+                <a:tc>
+                  <a:txBody>
+                    <a:bodyPr wrap="square"/>
+                    <a:lstStyle/>
+                    <a:p>
+                      <a:pPr algn="ctr" marL="0" indent="0">
+                        <a:spcAft>
+                          <a:spcPts val="0"/>
+                        </a:spcAft>
+                        <a:buNone/>
+                      </a:pPr>
+                      <a:r>
+                        <a:rPr sz="1200" b="0" i="0">
+                          <a:solidFill>
+                            <a:srgbClr val="1A1A1A"/>
+                          </a:solidFill>
+                          <a:latin typeface="Arial"/>
+                          <a:cs typeface="Arial"/>
+                          <a:ea typeface="Arial"/>
+                        </a:rPr>
+                        <a:t>4.25</a:t>
+                      </a:r>
+                    </a:p>
+                  </a:txBody>
+                  <a:tcPr anchor="ctr">
+                    <a:solidFill>
+                      <a:srgbClr val="E4ECF7"/>
+                    </a:solidFill>
+                  </a:tcPr>
+                </a:tc>
+                <a:tc>
+                  <a:txBody>
+                    <a:bodyPr wrap="square"/>
+                    <a:lstStyle/>
+                    <a:p>
+                      <a:pPr algn="ctr" marL="0" indent="0">
+                        <a:spcAft>
+                          <a:spcPts val="0"/>
+                        </a:spcAft>
+                        <a:buNone/>
+                      </a:pPr>
+                      <a:r>
+                        <a:rPr sz="1200" b="0" i="0">
+                          <a:solidFill>
+                            <a:srgbClr val="1A1A1A"/>
+                          </a:solidFill>
+                          <a:latin typeface="Arial"/>
+                          <a:cs typeface="Arial"/>
+                          <a:ea typeface="Arial"/>
+                        </a:rPr>
+                        <a:t>0.90</a:t>
+                      </a:r>
+                    </a:p>
+                  </a:txBody>
+                  <a:tcPr anchor="ctr">
+                    <a:solidFill>
+                      <a:srgbClr val="E4ECF7"/>
+                    </a:solidFill>
+                  </a:tcPr>
+                </a:tc>
+                <a:tc>
+                  <a:txBody>
+                    <a:bodyPr wrap="square"/>
+                    <a:lstStyle/>
+                    <a:p>
+                      <a:pPr algn="ctr" marL="0" indent="0">
+                        <a:spcAft>
+                          <a:spcPts val="0"/>
+                        </a:spcAft>
+                        <a:buNone/>
+                      </a:pPr>
+                      <a:r>
+                        <a:rPr sz="1200" b="0" i="0">
+                          <a:solidFill>
+                            <a:srgbClr val="1A1A1A"/>
+                          </a:solidFill>
+                          <a:latin typeface="Arial"/>
+                          <a:cs typeface="Arial"/>
+                          <a:ea typeface="Arial"/>
+                        </a:rPr>
+                        <a:t>21.9</a:t>
+                      </a:r>
+                    </a:p>
+                  </a:txBody>
+                  <a:tcPr anchor="ctr">
+                    <a:solidFill>
+                      <a:srgbClr val="E4ECF7"/>
+                    </a:solidFill>
+                  </a:tcPr>
+                </a:tc>
+              </a:tr>
+              <a:tr h="347472">
+                <a:tc>
+                  <a:txBody>
+                    <a:bodyPr wrap="square"/>
+                    <a:lstStyle/>
+                    <a:p>
+                      <a:pPr algn="l" marL="0" indent="0">
+                        <a:spcAft>
+                          <a:spcPts val="0"/>
+                        </a:spcAft>
+                        <a:buNone/>
+                      </a:pPr>
+                      <a:r>
+                        <a:rPr sz="1200" b="0" i="0">
+                          <a:solidFill>
+                            <a:srgbClr val="1A1A1A"/>
+                          </a:solidFill>
+                          <a:latin typeface="Arial"/>
+                          <a:cs typeface="Arial"/>
+                          <a:ea typeface="Arial"/>
+                        </a:rPr>
+                        <a:t>30 min</a:t>
+                      </a:r>
+                    </a:p>
+                  </a:txBody>
+                  <a:tcPr anchor="ctr">
+                    <a:solidFill>
+                      <a:srgbClr val="FFFFFF"/>
+                    </a:solidFill>
+                  </a:tcPr>
+                </a:tc>
+                <a:tc>
+                  <a:txBody>
+                    <a:bodyPr wrap="square"/>
+                    <a:lstStyle/>
+                    <a:p>
+                      <a:pPr algn="ctr" marL="0" indent="0">
+                        <a:spcAft>
+                          <a:spcPts val="0"/>
+                        </a:spcAft>
+                        <a:buNone/>
+                      </a:pPr>
+                      <a:r>
+                        <a:rPr sz="1200" b="0" i="0">
+                          <a:solidFill>
+                            <a:srgbClr val="1A1A1A"/>
+                          </a:solidFill>
+                          <a:latin typeface="Arial"/>
+                          <a:cs typeface="Arial"/>
+                          <a:ea typeface="Arial"/>
+                        </a:rPr>
+                        <a:t>5.50</a:t>
+                      </a:r>
+                    </a:p>
+                  </a:txBody>
+                  <a:tcPr anchor="ctr">
+                    <a:solidFill>
+                      <a:srgbClr val="FFFFFF"/>
+                    </a:solidFill>
+                  </a:tcPr>
+                </a:tc>
+                <a:tc>
+                  <a:txBody>
+                    <a:bodyPr wrap="square"/>
+                    <a:lstStyle/>
+                    <a:p>
+                      <a:pPr algn="ctr" marL="0" indent="0">
+                        <a:spcAft>
+                          <a:spcPts val="0"/>
+                        </a:spcAft>
+                        <a:buNone/>
+                      </a:pPr>
+                      <a:r>
+                        <a:rPr sz="1200" b="0" i="0">
+                          <a:solidFill>
+                            <a:srgbClr val="1A1A1A"/>
+                          </a:solidFill>
+                          <a:latin typeface="Arial"/>
+                          <a:cs typeface="Arial"/>
+                          <a:ea typeface="Arial"/>
+                        </a:rPr>
+                        <a:t>6.17</a:t>
+                      </a:r>
+                    </a:p>
+                  </a:txBody>
+                  <a:tcPr anchor="ctr">
+                    <a:solidFill>
+                      <a:srgbClr val="FFFFFF"/>
+                    </a:solidFill>
+                  </a:tcPr>
+                </a:tc>
+                <a:tc>
+                  <a:txBody>
+                    <a:bodyPr wrap="square"/>
+                    <a:lstStyle/>
+                    <a:p>
+                      <a:pPr algn="ctr" marL="0" indent="0">
+                        <a:spcAft>
+                          <a:spcPts val="0"/>
+                        </a:spcAft>
+                        <a:buNone/>
+                      </a:pPr>
+                      <a:r>
+                        <a:rPr sz="1200" b="0" i="0">
+                          <a:solidFill>
+                            <a:srgbClr val="1A1A1A"/>
+                          </a:solidFill>
+                          <a:latin typeface="Arial"/>
+                          <a:cs typeface="Arial"/>
+                          <a:ea typeface="Arial"/>
+                        </a:rPr>
+                        <a:t>0.87</a:t>
+                      </a:r>
+                    </a:p>
+                  </a:txBody>
+                  <a:tcPr anchor="ctr">
+                    <a:solidFill>
+                      <a:srgbClr val="FFFFFF"/>
+                    </a:solidFill>
+                  </a:tcPr>
+                </a:tc>
+                <a:tc>
+                  <a:txBody>
+                    <a:bodyPr wrap="square"/>
+                    <a:lstStyle/>
+                    <a:p>
+                      <a:pPr algn="ctr" marL="0" indent="0">
+                        <a:spcAft>
+                          <a:spcPts val="0"/>
+                        </a:spcAft>
+                        <a:buNone/>
+                      </a:pPr>
+                      <a:r>
+                        <a:rPr sz="1200" b="0" i="0">
+                          <a:solidFill>
+                            <a:srgbClr val="1A1A1A"/>
+                          </a:solidFill>
+                          <a:latin typeface="Arial"/>
+                          <a:cs typeface="Arial"/>
+                          <a:ea typeface="Arial"/>
+                        </a:rPr>
+                        <a:t>24.9</a:t>
+                      </a:r>
+                    </a:p>
+                  </a:txBody>
+                  <a:tcPr anchor="ctr">
+                    <a:solidFill>
+                      <a:srgbClr val="FFFFFF"/>
+                    </a:solidFill>
+                  </a:tcPr>
+                </a:tc>
+              </a:tr>
+              <a:tr h="347472">
+                <a:tc>
+                  <a:txBody>
+                    <a:bodyPr wrap="square"/>
+                    <a:lstStyle/>
+                    <a:p>
+                      <a:pPr algn="l" marL="0" indent="0">
+                        <a:spcAft>
+                          <a:spcPts val="0"/>
+                        </a:spcAft>
+                        <a:buNone/>
+                      </a:pPr>
+                      <a:r>
+                        <a:rPr sz="1200" b="0" i="0">
+                          <a:solidFill>
+                            <a:srgbClr val="1A1A1A"/>
+                          </a:solidFill>
+                          <a:latin typeface="Arial"/>
+                          <a:cs typeface="Arial"/>
+                          <a:ea typeface="Arial"/>
+                        </a:rPr>
+                        <a:t>60 min</a:t>
+                      </a:r>
+                    </a:p>
+                  </a:txBody>
+                  <a:tcPr anchor="ctr">
+                    <a:solidFill>
+                      <a:srgbClr val="E4ECF7"/>
+                    </a:solidFill>
+                  </a:tcPr>
+                </a:tc>
+                <a:tc>
+                  <a:txBody>
+                    <a:bodyPr wrap="square"/>
+                    <a:lstStyle/>
+                    <a:p>
+                      <a:pPr algn="ctr" marL="0" indent="0">
+                        <a:spcAft>
+                          <a:spcPts val="0"/>
+                        </a:spcAft>
+                        <a:buNone/>
+                      </a:pPr>
+                      <a:r>
+                        <a:rPr sz="1200" b="0" i="0">
+                          <a:solidFill>
+                            <a:srgbClr val="1A1A1A"/>
+                          </a:solidFill>
+                          <a:latin typeface="Arial"/>
+                          <a:cs typeface="Arial"/>
+                          <a:ea typeface="Arial"/>
+                        </a:rPr>
+                        <a:t>5.25</a:t>
+                      </a:r>
+                    </a:p>
+                  </a:txBody>
+                  <a:tcPr anchor="ctr">
+                    <a:solidFill>
+                      <a:srgbClr val="E4ECF7"/>
+                    </a:solidFill>
+                  </a:tcPr>
+                </a:tc>
+                <a:tc>
+                  <a:txBody>
+                    <a:bodyPr wrap="square"/>
+                    <a:lstStyle/>
+                    <a:p>
+                      <a:pPr algn="ctr" marL="0" indent="0">
+                        <a:spcAft>
+                          <a:spcPts val="0"/>
+                        </a:spcAft>
+                        <a:buNone/>
+                      </a:pPr>
+                      <a:r>
+                        <a:rPr sz="1200" b="0" i="0">
+                          <a:solidFill>
+                            <a:srgbClr val="1A1A1A"/>
+                          </a:solidFill>
+                          <a:latin typeface="Arial"/>
+                          <a:cs typeface="Arial"/>
+                          <a:ea typeface="Arial"/>
+                        </a:rPr>
+                        <a:t>5.59</a:t>
+                      </a:r>
+                    </a:p>
+                  </a:txBody>
+                  <a:tcPr anchor="ctr">
+                    <a:solidFill>
+                      <a:srgbClr val="E4ECF7"/>
+                    </a:solidFill>
+                  </a:tcPr>
+                </a:tc>
+                <a:tc>
+                  <a:txBody>
+                    <a:bodyPr wrap="square"/>
+                    <a:lstStyle/>
+                    <a:p>
+                      <a:pPr algn="ctr" marL="0" indent="0">
+                        <a:spcAft>
+                          <a:spcPts val="0"/>
+                        </a:spcAft>
+                        <a:buNone/>
+                      </a:pPr>
+                      <a:r>
+                        <a:rPr sz="1200" b="0" i="0">
+                          <a:solidFill>
+                            <a:srgbClr val="1A1A1A"/>
+                          </a:solidFill>
+                          <a:latin typeface="Arial"/>
+                          <a:cs typeface="Arial"/>
+                          <a:ea typeface="Arial"/>
+                        </a:rPr>
+                        <a:t>0.92</a:t>
+                      </a:r>
+                    </a:p>
+                  </a:txBody>
+                  <a:tcPr anchor="ctr">
+                    <a:solidFill>
+                      <a:srgbClr val="E4ECF7"/>
+                    </a:solidFill>
+                  </a:tcPr>
+                </a:tc>
+                <a:tc>
+                  <a:txBody>
+                    <a:bodyPr wrap="square"/>
+                    <a:lstStyle/>
+                    <a:p>
+                      <a:pPr algn="ctr" marL="0" indent="0">
+                        <a:spcAft>
+                          <a:spcPts val="0"/>
+                        </a:spcAft>
+                        <a:buNone/>
+                      </a:pPr>
+                      <a:r>
+                        <a:rPr sz="1200" b="0" i="0">
+                          <a:solidFill>
+                            <a:srgbClr val="1A1A1A"/>
+                          </a:solidFill>
+                          <a:latin typeface="Arial"/>
+                          <a:cs typeface="Arial"/>
+                          <a:ea typeface="Arial"/>
+                        </a:rPr>
+                        <a:t>27.3</a:t>
+                      </a:r>
+                    </a:p>
+                  </a:txBody>
+                  <a:tcPr anchor="ctr">
+                    <a:solidFill>
+                      <a:srgbClr val="E4ECF7"/>
+                    </a:solidFill>
+                  </a:tcPr>
+                </a:tc>
+              </a:tr>
+              <a:tr h="347472">
+                <a:tc>
+                  <a:txBody>
+                    <a:bodyPr wrap="square"/>
+                    <a:lstStyle/>
+                    <a:p>
+                      <a:pPr algn="l" marL="0" indent="0">
+                        <a:spcAft>
+                          <a:spcPts val="0"/>
+                        </a:spcAft>
+                        <a:buNone/>
+                      </a:pPr>
+                      <a:r>
+                        <a:rPr sz="1200" b="0" i="0">
+                          <a:solidFill>
+                            <a:srgbClr val="1A1A1A"/>
+                          </a:solidFill>
+                          <a:latin typeface="Arial"/>
+                          <a:cs typeface="Arial"/>
+                          <a:ea typeface="Arial"/>
+                        </a:rPr>
+                        <a:t>Eligible links</a:t>
+                      </a:r>
+                    </a:p>
+                  </a:txBody>
+                  <a:tcPr anchor="ctr">
+                    <a:solidFill>
+                      <a:srgbClr val="FFFFFF"/>
+                    </a:solidFill>
+                  </a:tcPr>
+                </a:tc>
+                <a:tc gridSpan="4">
+                  <a:txBody>
+                    <a:bodyPr wrap="square"/>
+                    <a:lstStyle/>
+                    <a:p>
+                      <a:pPr algn="ctr" marL="0" indent="0">
+                        <a:spcAft>
+                          <a:spcPts val="0"/>
+                        </a:spcAft>
+                        <a:buNone/>
+                      </a:pPr>
+                      <a:r>
+                        <a:rPr sz="1200" b="0" i="0">
+                          <a:solidFill>
+                            <a:srgbClr val="1A1A1A"/>
+                          </a:solidFill>
+                          <a:latin typeface="Arial"/>
+                          <a:cs typeface="Arial"/>
+                          <a:ea typeface="Arial"/>
+                        </a:rPr>
+                        <a:t>3.96 / 5.14 / 4.65</a:t>
+                      </a:r>
+                    </a:p>
+                  </a:txBody>
+                  <a:tcPr anchor="ctr">
+                    <a:solidFill>
+                      <a:srgbClr val="FFFFFF"/>
+                    </a:solidFill>
+                  </a:tcPr>
+                </a:tc>
+                <a:tc hMerge="1">
+                  <a:txBody>
+                    <a:bodyPr/>
+                    <a:lstStyle/>
+                    <a:p/>
+                  </a:txBody>
+                  <a:tcPr/>
+                </a:tc>
+                <a:tc hMerge="1">
+                  <a:txBody>
+                    <a:bodyPr/>
+                    <a:lstStyle/>
+                    <a:p/>
+                  </a:txBody>
+                  <a:tcPr/>
+                </a:tc>
+                <a:tc hMerge="1">
+                  <a:txBody>
+                    <a:bodyPr/>
+                    <a:lstStyle/>
+                    <a:p/>
+                  </a:txBody>
+                  <a:tcPr/>
+                </a:tc>
+              </a:tr>
+            </a:tbl>
+          </a:graphicData>
+        </a:graphic>
+      </p:graphicFrame>
+      <p:sp>
+        <p:nvSpPr>
+          <p:cNvPr id="11" name="LIVE facts"/>
+          <p:cNvSpPr txBox="1"/>
+          <p:nvPr/>
+        </p:nvSpPr>
+        <p:spPr>
+          <a:xfrm>
+            <a:off x="6583680" y="3931920"/>
+            <a:ext cx="5715000" cy="1051560"/>
+          </a:xfrm>
+          <a:prstGeom prst="rect">
+            <a:avLst/>
+          </a:prstGeom>
+          <a:noFill/>
+        </p:spPr>
+        <p:txBody>
+          <a:bodyPr wrap="square" lIns="36576" rIns="36576" tIns="36576" bIns="36576" anchor="t"/>
+          <a:lstStyle/>
+          <a:p>
+            <a:pPr algn="l" marL="274320" indent="-228600">
+              <a:spcAft>
+                <a:spcPts val="300"/>
+              </a:spcAft>
+              <a:buFont typeface="Arial"/>
+              <a:buChar char="•"/>
+            </a:pPr>
+            <a:r>
+              <a:rPr sz="1200" b="0" i="0">
+                <a:solidFill>
+                  <a:srgbClr val="1A1A1A"/>
+                </a:solidFill>
+                <a:latin typeface="Arial"/>
+                <a:cs typeface="Arial"/>
+                <a:ea typeface="Arial"/>
+              </a:rPr>
+              <a:t>117 forecasts scored (39 per horizon), 0 pending, 0 late; lower MAE than persistence at all three horizons. Eligible-links row: n = 30 per horizon.</a:t>
+            </a:r>
+          </a:p>
+          <a:p>
+            <a:pPr algn="l" marL="274320" indent="-228600">
+              <a:spcAft>
+                <a:spcPts val="300"/>
+              </a:spcAft>
+              <a:buFont typeface="Arial"/>
+              <a:buChar char="•"/>
+            </a:pPr>
+            <a:r>
+              <a:rPr sz="1200" b="0" i="0">
+                <a:solidFill>
+                  <a:srgbClr val="1A1A1A"/>
+                </a:solidFill>
+                <a:latin typeface="Arial"/>
+                <a:cs typeface="Arial"/>
+                <a:ea typeface="Arial"/>
+              </a:rPr>
+              <a:t>3 origins: 13:40, 14:55, 16:05 UTC; data age at issue 148 / 89 / 104 min (mean 114); 13 of 16 links each, 3 withheld for missing recent records.</a:t>
+            </a:r>
+          </a:p>
+        </p:txBody>
+      </p:sp>
+      <p:sp>
+        <p:nvSpPr>
+          <p:cNvPr id="12" name="LIVE caveats"/>
+          <p:cNvSpPr txBox="1"/>
+          <p:nvPr/>
+        </p:nvSpPr>
+        <p:spPr>
+          <a:xfrm>
+            <a:off x="6583680" y="5029200"/>
+            <a:ext cx="5715000" cy="1371600"/>
+          </a:xfrm>
+          <a:prstGeom prst="rect">
+            <a:avLst/>
+          </a:prstGeom>
+          <a:noFill/>
+        </p:spPr>
+        <p:txBody>
+          <a:bodyPr wrap="square" lIns="36576" rIns="36576" tIns="36576" bIns="36576" anchor="t"/>
+          <a:lstStyle/>
+          <a:p>
+            <a:pPr algn="l" marL="274320" indent="-228600">
+              <a:spcAft>
+                <a:spcPts val="300"/>
+              </a:spcAft>
+              <a:buFont typeface="Arial"/>
+              <a:buChar char="•"/>
+            </a:pPr>
+            <a:r>
+              <a:rPr sz="1200" b="1" i="0">
+                <a:solidFill>
+                  <a:srgbClr val="1A1A1A"/>
+                </a:solidFill>
+                <a:latin typeface="Arial"/>
+                <a:cs typeface="Arial"/>
+                <a:ea typeface="Arial"/>
+              </a:rPr>
+              <a:t>A forecast at the feed's own latency of bins it had not yet published, with its data age; not a real-time forecast.</a:t>
+            </a:r>
+          </a:p>
+          <a:p>
+            <a:pPr algn="l" marL="274320" indent="-228600">
+              <a:spcAft>
+                <a:spcPts val="300"/>
+              </a:spcAft>
+              <a:buFont typeface="Arial"/>
+              <a:buChar char="•"/>
+            </a:pPr>
+            <a:r>
+              <a:rPr sz="1200" b="1" i="0">
+                <a:solidFill>
+                  <a:srgbClr val="1A1A1A"/>
+                </a:solidFill>
+                <a:latin typeface="Arial"/>
+                <a:cs typeface="Arial"/>
+                <a:ea typeface="Arial"/>
+              </a:rPr>
+              <a:t>One afternoon, three origins, not a second test set.</a:t>
+            </a:r>
+          </a:p>
+          <a:p>
+            <a:pPr algn="l" marL="274320" indent="-228600">
+              <a:spcAft>
+                <a:spcPts val="300"/>
+              </a:spcAft>
+              <a:buFont typeface="Arial"/>
+              <a:buChar char="•"/>
+            </a:pPr>
+            <a:r>
+              <a:rPr sz="1200" b="1" i="0">
+                <a:solidFill>
+                  <a:srgbClr val="1A1A1A"/>
+                </a:solidFill>
+                <a:latin typeface="Arial"/>
+                <a:cs typeface="Arial"/>
+                <a:ea typeface="Arial"/>
+              </a:rPr>
+              <a:t>The wall-clock protocol stays NOT RUN: on 28 and 29 Oct the feed ran 1.7–4.3 h behind and every link was withheld.</a:t>
+            </a:r>
+          </a:p>
+        </p:txBody>
+      </p:sp>
+      <p:sp>
+        <p:nvSpPr>
+          <p:cNvPr id="13" name="TextBox 12"/>
+          <p:cNvSpPr txBox="1"/>
+          <p:nvPr/>
+        </p:nvSpPr>
+        <p:spPr>
+          <a:xfrm>
+            <a:off x="6583680" y="6419088"/>
+            <a:ext cx="5715000" cy="274320"/>
+          </a:xfrm>
+          <a:prstGeom prst="rect">
+            <a:avLst/>
+          </a:prstGeom>
+          <a:noFill/>
+        </p:spPr>
+        <p:txBody>
+          <a:bodyPr wrap="square" lIns="18288" rIns="18288" tIns="18288" bIns="18288" anchor="t"/>
+          <a:lstStyle/>
+          <a:p>
+            <a:pPr algn="l" marL="0" indent="0">
+              <a:spcAft>
+                <a:spcPts val="0"/>
+              </a:spcAft>
+              <a:buNone/>
+            </a:pPr>
+            <a:r>
+              <a:rPr sz="1000" b="0" i="0">
+                <a:solidFill>
+                  <a:srgbClr val="555F6B"/>
+                </a:solidFill>
+                <a:latin typeface="Arial"/>
+                <a:cs typeface="Arial"/>
+                <a:ea typeface="Arial"/>
+              </a:rPr>
+              <a:t>Source: reports/experiments/live_metrics.csv, artifacts/live/scored.csv (claims C50–C52)</a:t>
+            </a:r>
+          </a:p>
+        </p:txBody>
+      </p:sp>
+    </p:spTree>
+    <p:extLst>
+      <p:ext uri="{BB962C8B-B14F-4D97-AF65-F5344CB8AC3E}">
+        <p14:creationId xmlns:p14="http://schemas.microsoft.com/office/powerpoint/2010/main" val="3187296211"/>
+      </p:ext>
+    </p:extLst>
+  </p:cSld>
+  <p:clrMapOvr>
+    <a:masterClrMapping/>
+  </p:clrMapOvr>
+</p:sld>
+</file>
+
+<file path=ppt/slides/slide24.xml><?xml version="1.0" encoding="utf-8"?>
+<p:sld xmlns:a="http://schemas.openxmlformats.org/drawingml/2006/main" xmlns:r="http://schemas.openxmlformats.org/officeDocument/2006/relationships" xmlns:p="http://schemas.openxmlformats.org/presentationml/2006/main">
+  <p:cSld>
+    <p:spTree>
+      <p:nvGrpSpPr>
+        <p:cNvPr id="1" name=""/>
+        <p:cNvGrpSpPr/>
+        <p:nvPr/>
+      </p:nvGrpSpPr>
+      <p:grpSpPr>
+        <a:xfrm>
+          <a:off x="0" y="0"/>
+          <a:ext cx="0" cy="0"/>
+          <a:chOff x="0" y="0"/>
+          <a:chExt cx="0" cy="0"/>
+        </a:xfrm>
+      </p:grpSpPr>
+      <p:sp>
+        <p:nvSpPr>
+          <p:cNvPr id="2" name="Title 1"/>
+          <p:cNvSpPr>
+            <a:spLocks noGrp="1"/>
+          </p:cNvSpPr>
+          <p:nvPr>
+            <p:ph type="title"/>
+          </p:nvPr>
+        </p:nvSpPr>
+        <p:spPr>
+          <a:xfrm>
+            <a:off x="0" y="0"/>
+            <a:ext cx="12801600" cy="1512146"/>
+          </a:xfrm>
+          <a:solidFill>
+            <a:srgbClr val="558ED5"/>
+          </a:solidFill>
+        </p:spPr>
+        <p:txBody>
+          <a:bodyPr>
+            <a:normAutofit/>
+          </a:bodyPr>
+          <a:lstStyle/>
+          <a:p>
+            <a:r>
+              <a:rPr lang="en-US" sz="3600" b="1" dirty="0">
+                <a:solidFill>
+                  <a:schemeClr val="bg1"/>
+                </a:solidFill>
+                <a:latin typeface="Arial" panose="020B0604020202020204" pitchFamily="34" charset="0"/>
+                <a:cs typeface="Arial" panose="020B0604020202020204" pitchFamily="34" charset="0"/>
+              </a:rPr>
+              <a:t>9. RESULTS &amp; OUTCOMES (CONTD.)</a:t>
+            </a:r>
+          </a:p>
+        </p:txBody>
+      </p:sp>
+      <p:sp>
+        <p:nvSpPr>
+          <p:cNvPr id="4" name="Slide Number Placeholder 3"/>
+          <p:cNvSpPr>
+            <a:spLocks noGrp="1"/>
+          </p:cNvSpPr>
+          <p:nvPr>
+            <p:ph type="sldNum" sz="quarter" idx="12"/>
+          </p:nvPr>
+        </p:nvSpPr>
+        <p:spPr/>
+        <p:txBody>
+          <a:bodyPr/>
+          <a:lstStyle/>
+          <a:p>
+            <a:fld id="{C02A2637-A5A3-49FA-B214-6E67543099EF}" type="slidenum">
+              <a:rPr lang="en-US" smtClean="0"/>
+              <a:t>24</a:t>
             </a:fld>
             <a:endParaRPr lang="en-US"/>
           </a:p>
@@ -16208,7 +17449,7 @@
                 <a:cs typeface="Arial"/>
                 <a:ea typeface="Arial"/>
               </a:rPr>
-              <a:t>LIVE observational mode is built but not yet run on the public feed</a:t>
+              <a:t>LIVE: one afternoon at the feed's ~2 h latency; the wall-clock protocol stayed NOT RUN (feed 1.7–4.3 h behind)</a:t>
             </a:r>
           </a:p>
           <a:p>
@@ -16453,7 +17694,7 @@
                 <a:cs typeface="Arial"/>
                 <a:ea typeface="Arial"/>
               </a:rPr>
-              <a:t>Next: run LIVE mode on the public feed and score its saved forecasts</a:t>
+              <a:t>Next: repeat the LIVE run over more days; wall-clock forecasts need a fresher feed</a:t>
             </a:r>
           </a:p>
           <a:p>
@@ -16511,7 +17752,7 @@
 </p:sld>
 </file>
 
-<file path=ppt/slides/slide24.xml><?xml version="1.0" encoding="utf-8"?>
+<file path=ppt/slides/slide25.xml><?xml version="1.0" encoding="utf-8"?>
 <p:sld xmlns:a="http://schemas.openxmlformats.org/drawingml/2006/main" xmlns:r="http://schemas.openxmlformats.org/officeDocument/2006/relationships" xmlns:p="http://schemas.openxmlformats.org/presentationml/2006/main">
   <p:cSld>
     <p:spTree>
@@ -16611,7 +17852,7 @@
           <a:p>
             <a:fld id="{C02A2637-A5A3-49FA-B214-6E67543099EF}" type="slidenum">
               <a:rPr lang="en-US" smtClean="0"/>
-              <a:t>24</a:t>
+              <a:t>25</a:t>
             </a:fld>
             <a:endParaRPr lang="en-US"/>
           </a:p>
@@ -16879,7 +18120,7 @@
 </p:sld>
 </file>
 
-<file path=ppt/slides/slide25.xml><?xml version="1.0" encoding="utf-8"?>
+<file path=ppt/slides/slide26.xml><?xml version="1.0" encoding="utf-8"?>
 <p:sld xmlns:a="http://schemas.openxmlformats.org/drawingml/2006/main" xmlns:r="http://schemas.openxmlformats.org/officeDocument/2006/relationships" xmlns:p="http://schemas.openxmlformats.org/presentationml/2006/main">
   <p:cSld>
     <p:spTree>
@@ -16951,7 +18192,7 @@
           <a:p>
             <a:fld id="{C02A2637-A5A3-49FA-B214-6E67543099EF}" type="slidenum">
               <a:rPr lang="en-US" smtClean="0"/>
-              <a:t>25</a:t>
+              <a:t>26</a:t>
             </a:fld>
             <a:endParaRPr lang="en-US"/>
           </a:p>

</xml_diff>